<commit_message>
docs: compile presentation and demo explanation scripts into publication-grade PDFs
</commit_message>
<xml_diff>
--- a/CLIPMIND AI/docs/ClipMind_AI_Final_Presentation.pptx
+++ b/CLIPMIND AI/docs/ClipMind_AI_Final_Presentation.pptx
@@ -5,18 +5,18 @@
     <p:sldMasterId id="2147483648" r:id="rId1"/>
   </p:sldMasterIdLst>
   <p:sldIdLst>
-    <p:sldId id="256" r:id="rId7"/>
-    <p:sldId id="257" r:id="rId8"/>
-    <p:sldId id="258" r:id="rId9"/>
-    <p:sldId id="259" r:id="rId10"/>
-    <p:sldId id="260" r:id="rId11"/>
-    <p:sldId id="261" r:id="rId12"/>
-    <p:sldId id="262" r:id="rId13"/>
-    <p:sldId id="263" r:id="rId14"/>
-    <p:sldId id="264" r:id="rId15"/>
-    <p:sldId id="265" r:id="rId16"/>
+    <p:sldId id="256" r:id="rId2"/>
+    <p:sldId id="257" r:id="rId3"/>
+    <p:sldId id="258" r:id="rId4"/>
+    <p:sldId id="259" r:id="rId5"/>
+    <p:sldId id="260" r:id="rId6"/>
+    <p:sldId id="261" r:id="rId7"/>
+    <p:sldId id="262" r:id="rId8"/>
+    <p:sldId id="263" r:id="rId9"/>
+    <p:sldId id="264" r:id="rId10"/>
+    <p:sldId id="265" r:id="rId11"/>
   </p:sldIdLst>
-  <p:sldSz cx="12191695" cy="6858000" type="screen4x3"/>
+  <p:sldSz cx="12192000" cy="6858000"/>
   <p:notesSz cx="6858000" cy="9144000"/>
   <p:defaultTextStyle>
     <a:defPPr>
@@ -113,6 +113,22 @@
       </a:defRPr>
     </a:lvl9pPr>
   </p:defaultTextStyle>
+  <p:extLst>
+    <p:ext uri="{EFAFB233-063F-42B5-8137-9DF3F51BA10A}">
+      <p15:sldGuideLst xmlns:p15="http://schemas.microsoft.com/office/powerpoint/2012/main">
+        <p15:guide id="1" orient="horz" pos="2160">
+          <p15:clr>
+            <a:srgbClr val="A4A3A4"/>
+          </p15:clr>
+        </p15:guide>
+        <p15:guide id="2" pos="2880">
+          <p15:clr>
+            <a:srgbClr val="A4A3A4"/>
+          </p15:clr>
+        </p15:guide>
+      </p15:sldGuideLst>
+    </p:ext>
+  </p:extLst>
 </p:presentation>
 </file>
 
@@ -154,10 +170,9 @@
           <a:lstStyle/>
           <a:p>
             <a:r>
-              <a:rPr lang="en-US" smtClean="0"/>
+              <a:rPr lang="en-US"/>
               <a:t>Click to edit Master title style</a:t>
             </a:r>
-            <a:endParaRPr lang="en-US"/>
           </a:p>
         </p:txBody>
       </p:sp>
@@ -273,10 +288,9 @@
           </a:lstStyle>
           <a:p>
             <a:r>
-              <a:rPr lang="en-US" smtClean="0"/>
+              <a:rPr lang="en-US"/>
               <a:t>Click to edit Master subtitle style</a:t>
             </a:r>
-            <a:endParaRPr lang="en-US"/>
           </a:p>
         </p:txBody>
       </p:sp>
@@ -297,7 +311,7 @@
           <a:p>
             <a:fld id="{5BCAD085-E8A6-8845-BD4E-CB4CCA059FC4}" type="datetimeFigureOut">
               <a:rPr lang="en-US" smtClean="0"/>
-              <a:t>1/27/13</a:t>
+              <a:t>9/16/2026</a:t>
             </a:fld>
             <a:endParaRPr lang="en-US"/>
           </a:p>
@@ -391,10 +405,9 @@
           <a:lstStyle/>
           <a:p>
             <a:r>
-              <a:rPr lang="en-US" smtClean="0"/>
+              <a:rPr lang="en-US"/>
               <a:t>Click to edit Master title style</a:t>
             </a:r>
-            <a:endParaRPr lang="en-US"/>
           </a:p>
         </p:txBody>
       </p:sp>
@@ -415,38 +428,37 @@
           <a:p>
             <a:pPr lvl="0"/>
             <a:r>
-              <a:rPr lang="en-US" smtClean="0"/>
+              <a:rPr lang="en-US"/>
               <a:t>Click to edit Master text styles</a:t>
             </a:r>
           </a:p>
           <a:p>
             <a:pPr lvl="1"/>
             <a:r>
-              <a:rPr lang="en-US" smtClean="0"/>
+              <a:rPr lang="en-US"/>
               <a:t>Second level</a:t>
             </a:r>
           </a:p>
           <a:p>
             <a:pPr lvl="2"/>
             <a:r>
-              <a:rPr lang="en-US" smtClean="0"/>
+              <a:rPr lang="en-US"/>
               <a:t>Third level</a:t>
             </a:r>
           </a:p>
           <a:p>
             <a:pPr lvl="3"/>
             <a:r>
-              <a:rPr lang="en-US" smtClean="0"/>
+              <a:rPr lang="en-US"/>
               <a:t>Fourth level</a:t>
             </a:r>
           </a:p>
           <a:p>
             <a:pPr lvl="4"/>
             <a:r>
-              <a:rPr lang="en-US" smtClean="0"/>
+              <a:rPr lang="en-US"/>
               <a:t>Fifth level</a:t>
             </a:r>
-            <a:endParaRPr lang="en-US"/>
           </a:p>
         </p:txBody>
       </p:sp>
@@ -467,7 +479,7 @@
           <a:p>
             <a:fld id="{5BCAD085-E8A6-8845-BD4E-CB4CCA059FC4}" type="datetimeFigureOut">
               <a:rPr lang="en-US" smtClean="0"/>
-              <a:t>1/27/13</a:t>
+              <a:t>9/16/2026</a:t>
             </a:fld>
             <a:endParaRPr lang="en-US"/>
           </a:p>
@@ -566,10 +578,9 @@
           <a:lstStyle/>
           <a:p>
             <a:r>
-              <a:rPr lang="en-US" smtClean="0"/>
+              <a:rPr lang="en-US"/>
               <a:t>Click to edit Master title style</a:t>
             </a:r>
-            <a:endParaRPr lang="en-US"/>
           </a:p>
         </p:txBody>
       </p:sp>
@@ -595,38 +606,37 @@
           <a:p>
             <a:pPr lvl="0"/>
             <a:r>
-              <a:rPr lang="en-US" smtClean="0"/>
+              <a:rPr lang="en-US"/>
               <a:t>Click to edit Master text styles</a:t>
             </a:r>
           </a:p>
           <a:p>
             <a:pPr lvl="1"/>
             <a:r>
-              <a:rPr lang="en-US" smtClean="0"/>
+              <a:rPr lang="en-US"/>
               <a:t>Second level</a:t>
             </a:r>
           </a:p>
           <a:p>
             <a:pPr lvl="2"/>
             <a:r>
-              <a:rPr lang="en-US" smtClean="0"/>
+              <a:rPr lang="en-US"/>
               <a:t>Third level</a:t>
             </a:r>
           </a:p>
           <a:p>
             <a:pPr lvl="3"/>
             <a:r>
-              <a:rPr lang="en-US" smtClean="0"/>
+              <a:rPr lang="en-US"/>
               <a:t>Fourth level</a:t>
             </a:r>
           </a:p>
           <a:p>
             <a:pPr lvl="4"/>
             <a:r>
-              <a:rPr lang="en-US" smtClean="0"/>
+              <a:rPr lang="en-US"/>
               <a:t>Fifth level</a:t>
             </a:r>
-            <a:endParaRPr lang="en-US"/>
           </a:p>
         </p:txBody>
       </p:sp>
@@ -647,7 +657,7 @@
           <a:p>
             <a:fld id="{5BCAD085-E8A6-8845-BD4E-CB4CCA059FC4}" type="datetimeFigureOut">
               <a:rPr lang="en-US" smtClean="0"/>
-              <a:t>1/27/13</a:t>
+              <a:t>9/16/2026</a:t>
             </a:fld>
             <a:endParaRPr lang="en-US"/>
           </a:p>
@@ -741,10 +751,9 @@
           <a:lstStyle/>
           <a:p>
             <a:r>
-              <a:rPr lang="en-US" smtClean="0"/>
+              <a:rPr lang="en-US"/>
               <a:t>Click to edit Master title style</a:t>
             </a:r>
-            <a:endParaRPr lang="en-US"/>
           </a:p>
         </p:txBody>
       </p:sp>
@@ -765,38 +774,37 @@
           <a:p>
             <a:pPr lvl="0"/>
             <a:r>
-              <a:rPr lang="en-US" smtClean="0"/>
+              <a:rPr lang="en-US"/>
               <a:t>Click to edit Master text styles</a:t>
             </a:r>
           </a:p>
           <a:p>
             <a:pPr lvl="1"/>
             <a:r>
-              <a:rPr lang="en-US" smtClean="0"/>
+              <a:rPr lang="en-US"/>
               <a:t>Second level</a:t>
             </a:r>
           </a:p>
           <a:p>
             <a:pPr lvl="2"/>
             <a:r>
-              <a:rPr lang="en-US" smtClean="0"/>
+              <a:rPr lang="en-US"/>
               <a:t>Third level</a:t>
             </a:r>
           </a:p>
           <a:p>
             <a:pPr lvl="3"/>
             <a:r>
-              <a:rPr lang="en-US" smtClean="0"/>
+              <a:rPr lang="en-US"/>
               <a:t>Fourth level</a:t>
             </a:r>
           </a:p>
           <a:p>
             <a:pPr lvl="4"/>
             <a:r>
-              <a:rPr lang="en-US" smtClean="0"/>
+              <a:rPr lang="en-US"/>
               <a:t>Fifth level</a:t>
             </a:r>
-            <a:endParaRPr lang="en-US"/>
           </a:p>
         </p:txBody>
       </p:sp>
@@ -817,7 +825,7 @@
           <a:p>
             <a:fld id="{5BCAD085-E8A6-8845-BD4E-CB4CCA059FC4}" type="datetimeFigureOut">
               <a:rPr lang="en-US" smtClean="0"/>
-              <a:t>1/27/13</a:t>
+              <a:t>9/16/2026</a:t>
             </a:fld>
             <a:endParaRPr lang="en-US"/>
           </a:p>
@@ -920,10 +928,9 @@
           </a:lstStyle>
           <a:p>
             <a:r>
-              <a:rPr lang="en-US" smtClean="0"/>
+              <a:rPr lang="en-US"/>
               <a:t>Click to edit Master title style</a:t>
             </a:r>
-            <a:endParaRPr lang="en-US"/>
           </a:p>
         </p:txBody>
       </p:sp>
@@ -1040,7 +1047,7 @@
           <a:p>
             <a:pPr lvl="0"/>
             <a:r>
-              <a:rPr lang="en-US" smtClean="0"/>
+              <a:rPr lang="en-US"/>
               <a:t>Click to edit Master text styles</a:t>
             </a:r>
           </a:p>
@@ -1063,7 +1070,7 @@
           <a:p>
             <a:fld id="{5BCAD085-E8A6-8845-BD4E-CB4CCA059FC4}" type="datetimeFigureOut">
               <a:rPr lang="en-US" smtClean="0"/>
-              <a:t>1/27/13</a:t>
+              <a:t>9/16/2026</a:t>
             </a:fld>
             <a:endParaRPr lang="en-US"/>
           </a:p>
@@ -1157,10 +1164,9 @@
           <a:lstStyle/>
           <a:p>
             <a:r>
-              <a:rPr lang="en-US" smtClean="0"/>
+              <a:rPr lang="en-US"/>
               <a:t>Click to edit Master title style</a:t>
             </a:r>
-            <a:endParaRPr lang="en-US"/>
           </a:p>
         </p:txBody>
       </p:sp>
@@ -1214,38 +1220,37 @@
           <a:p>
             <a:pPr lvl="0"/>
             <a:r>
-              <a:rPr lang="en-US" smtClean="0"/>
+              <a:rPr lang="en-US"/>
               <a:t>Click to edit Master text styles</a:t>
             </a:r>
           </a:p>
           <a:p>
             <a:pPr lvl="1"/>
             <a:r>
-              <a:rPr lang="en-US" smtClean="0"/>
+              <a:rPr lang="en-US"/>
               <a:t>Second level</a:t>
             </a:r>
           </a:p>
           <a:p>
             <a:pPr lvl="2"/>
             <a:r>
-              <a:rPr lang="en-US" smtClean="0"/>
+              <a:rPr lang="en-US"/>
               <a:t>Third level</a:t>
             </a:r>
           </a:p>
           <a:p>
             <a:pPr lvl="3"/>
             <a:r>
-              <a:rPr lang="en-US" smtClean="0"/>
+              <a:rPr lang="en-US"/>
               <a:t>Fourth level</a:t>
             </a:r>
           </a:p>
           <a:p>
             <a:pPr lvl="4"/>
             <a:r>
-              <a:rPr lang="en-US" smtClean="0"/>
+              <a:rPr lang="en-US"/>
               <a:t>Fifth level</a:t>
             </a:r>
-            <a:endParaRPr lang="en-US"/>
           </a:p>
         </p:txBody>
       </p:sp>
@@ -1299,38 +1304,37 @@
           <a:p>
             <a:pPr lvl="0"/>
             <a:r>
-              <a:rPr lang="en-US" smtClean="0"/>
+              <a:rPr lang="en-US"/>
               <a:t>Click to edit Master text styles</a:t>
             </a:r>
           </a:p>
           <a:p>
             <a:pPr lvl="1"/>
             <a:r>
-              <a:rPr lang="en-US" smtClean="0"/>
+              <a:rPr lang="en-US"/>
               <a:t>Second level</a:t>
             </a:r>
           </a:p>
           <a:p>
             <a:pPr lvl="2"/>
             <a:r>
-              <a:rPr lang="en-US" smtClean="0"/>
+              <a:rPr lang="en-US"/>
               <a:t>Third level</a:t>
             </a:r>
           </a:p>
           <a:p>
             <a:pPr lvl="3"/>
             <a:r>
-              <a:rPr lang="en-US" smtClean="0"/>
+              <a:rPr lang="en-US"/>
               <a:t>Fourth level</a:t>
             </a:r>
           </a:p>
           <a:p>
             <a:pPr lvl="4"/>
             <a:r>
-              <a:rPr lang="en-US" smtClean="0"/>
+              <a:rPr lang="en-US"/>
               <a:t>Fifth level</a:t>
             </a:r>
-            <a:endParaRPr lang="en-US"/>
           </a:p>
         </p:txBody>
       </p:sp>
@@ -1351,7 +1355,7 @@
           <a:p>
             <a:fld id="{5BCAD085-E8A6-8845-BD4E-CB4CCA059FC4}" type="datetimeFigureOut">
               <a:rPr lang="en-US" smtClean="0"/>
-              <a:t>1/27/13</a:t>
+              <a:t>9/16/2026</a:t>
             </a:fld>
             <a:endParaRPr lang="en-US"/>
           </a:p>
@@ -1449,10 +1453,9 @@
           </a:lstStyle>
           <a:p>
             <a:r>
-              <a:rPr lang="en-US" smtClean="0"/>
+              <a:rPr lang="en-US"/>
               <a:t>Click to edit Master title style</a:t>
             </a:r>
-            <a:endParaRPr lang="en-US"/>
           </a:p>
         </p:txBody>
       </p:sp>
@@ -1515,7 +1518,7 @@
           <a:p>
             <a:pPr lvl="0"/>
             <a:r>
-              <a:rPr lang="en-US" smtClean="0"/>
+              <a:rPr lang="en-US"/>
               <a:t>Click to edit Master text styles</a:t>
             </a:r>
           </a:p>
@@ -1571,38 +1574,37 @@
           <a:p>
             <a:pPr lvl="0"/>
             <a:r>
-              <a:rPr lang="en-US" smtClean="0"/>
+              <a:rPr lang="en-US"/>
               <a:t>Click to edit Master text styles</a:t>
             </a:r>
           </a:p>
           <a:p>
             <a:pPr lvl="1"/>
             <a:r>
-              <a:rPr lang="en-US" smtClean="0"/>
+              <a:rPr lang="en-US"/>
               <a:t>Second level</a:t>
             </a:r>
           </a:p>
           <a:p>
             <a:pPr lvl="2"/>
             <a:r>
-              <a:rPr lang="en-US" smtClean="0"/>
+              <a:rPr lang="en-US"/>
               <a:t>Third level</a:t>
             </a:r>
           </a:p>
           <a:p>
             <a:pPr lvl="3"/>
             <a:r>
-              <a:rPr lang="en-US" smtClean="0"/>
+              <a:rPr lang="en-US"/>
               <a:t>Fourth level</a:t>
             </a:r>
           </a:p>
           <a:p>
             <a:pPr lvl="4"/>
             <a:r>
-              <a:rPr lang="en-US" smtClean="0"/>
+              <a:rPr lang="en-US"/>
               <a:t>Fifth level</a:t>
             </a:r>
-            <a:endParaRPr lang="en-US"/>
           </a:p>
         </p:txBody>
       </p:sp>
@@ -1665,7 +1667,7 @@
           <a:p>
             <a:pPr lvl="0"/>
             <a:r>
-              <a:rPr lang="en-US" smtClean="0"/>
+              <a:rPr lang="en-US"/>
               <a:t>Click to edit Master text styles</a:t>
             </a:r>
           </a:p>
@@ -1721,38 +1723,37 @@
           <a:p>
             <a:pPr lvl="0"/>
             <a:r>
-              <a:rPr lang="en-US" smtClean="0"/>
+              <a:rPr lang="en-US"/>
               <a:t>Click to edit Master text styles</a:t>
             </a:r>
           </a:p>
           <a:p>
             <a:pPr lvl="1"/>
             <a:r>
-              <a:rPr lang="en-US" smtClean="0"/>
+              <a:rPr lang="en-US"/>
               <a:t>Second level</a:t>
             </a:r>
           </a:p>
           <a:p>
             <a:pPr lvl="2"/>
             <a:r>
-              <a:rPr lang="en-US" smtClean="0"/>
+              <a:rPr lang="en-US"/>
               <a:t>Third level</a:t>
             </a:r>
           </a:p>
           <a:p>
             <a:pPr lvl="3"/>
             <a:r>
-              <a:rPr lang="en-US" smtClean="0"/>
+              <a:rPr lang="en-US"/>
               <a:t>Fourth level</a:t>
             </a:r>
           </a:p>
           <a:p>
             <a:pPr lvl="4"/>
             <a:r>
-              <a:rPr lang="en-US" smtClean="0"/>
+              <a:rPr lang="en-US"/>
               <a:t>Fifth level</a:t>
             </a:r>
-            <a:endParaRPr lang="en-US"/>
           </a:p>
         </p:txBody>
       </p:sp>
@@ -1773,7 +1774,7 @@
           <a:p>
             <a:fld id="{5BCAD085-E8A6-8845-BD4E-CB4CCA059FC4}" type="datetimeFigureOut">
               <a:rPr lang="en-US" smtClean="0"/>
-              <a:t>1/27/13</a:t>
+              <a:t>9/16/2026</a:t>
             </a:fld>
             <a:endParaRPr lang="en-US"/>
           </a:p>
@@ -1867,10 +1868,9 @@
           <a:lstStyle/>
           <a:p>
             <a:r>
-              <a:rPr lang="en-US" smtClean="0"/>
+              <a:rPr lang="en-US"/>
               <a:t>Click to edit Master title style</a:t>
             </a:r>
-            <a:endParaRPr lang="en-US"/>
           </a:p>
         </p:txBody>
       </p:sp>
@@ -1891,7 +1891,7 @@
           <a:p>
             <a:fld id="{5BCAD085-E8A6-8845-BD4E-CB4CCA059FC4}" type="datetimeFigureOut">
               <a:rPr lang="en-US" smtClean="0"/>
-              <a:t>1/27/13</a:t>
+              <a:t>9/16/2026</a:t>
             </a:fld>
             <a:endParaRPr lang="en-US"/>
           </a:p>
@@ -1986,7 +1986,7 @@
           <a:p>
             <a:fld id="{5BCAD085-E8A6-8845-BD4E-CB4CCA059FC4}" type="datetimeFigureOut">
               <a:rPr lang="en-US" smtClean="0"/>
-              <a:t>1/27/13</a:t>
+              <a:t>9/16/2026</a:t>
             </a:fld>
             <a:endParaRPr lang="en-US"/>
           </a:p>
@@ -2089,10 +2089,9 @@
           </a:lstStyle>
           <a:p>
             <a:r>
-              <a:rPr lang="en-US" smtClean="0"/>
+              <a:rPr lang="en-US"/>
               <a:t>Click to edit Master title style</a:t>
             </a:r>
-            <a:endParaRPr lang="en-US"/>
           </a:p>
         </p:txBody>
       </p:sp>
@@ -2146,38 +2145,37 @@
           <a:p>
             <a:pPr lvl="0"/>
             <a:r>
-              <a:rPr lang="en-US" smtClean="0"/>
+              <a:rPr lang="en-US"/>
               <a:t>Click to edit Master text styles</a:t>
             </a:r>
           </a:p>
           <a:p>
             <a:pPr lvl="1"/>
             <a:r>
-              <a:rPr lang="en-US" smtClean="0"/>
+              <a:rPr lang="en-US"/>
               <a:t>Second level</a:t>
             </a:r>
           </a:p>
           <a:p>
             <a:pPr lvl="2"/>
             <a:r>
-              <a:rPr lang="en-US" smtClean="0"/>
+              <a:rPr lang="en-US"/>
               <a:t>Third level</a:t>
             </a:r>
           </a:p>
           <a:p>
             <a:pPr lvl="3"/>
             <a:r>
-              <a:rPr lang="en-US" smtClean="0"/>
+              <a:rPr lang="en-US"/>
               <a:t>Fourth level</a:t>
             </a:r>
           </a:p>
           <a:p>
             <a:pPr lvl="4"/>
             <a:r>
-              <a:rPr lang="en-US" smtClean="0"/>
+              <a:rPr lang="en-US"/>
               <a:t>Fifth level</a:t>
             </a:r>
-            <a:endParaRPr lang="en-US"/>
           </a:p>
         </p:txBody>
       </p:sp>
@@ -2240,7 +2238,7 @@
           <a:p>
             <a:pPr lvl="0"/>
             <a:r>
-              <a:rPr lang="en-US" smtClean="0"/>
+              <a:rPr lang="en-US"/>
               <a:t>Click to edit Master text styles</a:t>
             </a:r>
           </a:p>
@@ -2263,7 +2261,7 @@
           <a:p>
             <a:fld id="{5BCAD085-E8A6-8845-BD4E-CB4CCA059FC4}" type="datetimeFigureOut">
               <a:rPr lang="en-US" smtClean="0"/>
-              <a:t>1/27/13</a:t>
+              <a:t>9/16/2026</a:t>
             </a:fld>
             <a:endParaRPr lang="en-US"/>
           </a:p>
@@ -2366,10 +2364,9 @@
           </a:lstStyle>
           <a:p>
             <a:r>
-              <a:rPr lang="en-US" smtClean="0"/>
+              <a:rPr lang="en-US"/>
               <a:t>Click to edit Master title style</a:t>
             </a:r>
-            <a:endParaRPr lang="en-US"/>
           </a:p>
         </p:txBody>
       </p:sp>
@@ -2493,7 +2490,7 @@
           <a:p>
             <a:pPr lvl="0"/>
             <a:r>
-              <a:rPr lang="en-US" smtClean="0"/>
+              <a:rPr lang="en-US"/>
               <a:t>Click to edit Master text styles</a:t>
             </a:r>
           </a:p>
@@ -2516,7 +2513,7 @@
           <a:p>
             <a:fld id="{5BCAD085-E8A6-8845-BD4E-CB4CCA059FC4}" type="datetimeFigureOut">
               <a:rPr lang="en-US" smtClean="0"/>
-              <a:t>1/27/13</a:t>
+              <a:t>9/16/2026</a:t>
             </a:fld>
             <a:endParaRPr lang="en-US"/>
           </a:p>
@@ -2625,10 +2622,9 @@
           <a:lstStyle/>
           <a:p>
             <a:r>
-              <a:rPr lang="en-US" smtClean="0"/>
+              <a:rPr lang="en-US"/>
               <a:t>Click to edit Master title style</a:t>
             </a:r>
-            <a:endParaRPr lang="en-US"/>
           </a:p>
         </p:txBody>
       </p:sp>
@@ -2659,38 +2655,37 @@
           <a:p>
             <a:pPr lvl="0"/>
             <a:r>
-              <a:rPr lang="en-US" smtClean="0"/>
+              <a:rPr lang="en-US"/>
               <a:t>Click to edit Master text styles</a:t>
             </a:r>
           </a:p>
           <a:p>
             <a:pPr lvl="1"/>
             <a:r>
-              <a:rPr lang="en-US" smtClean="0"/>
+              <a:rPr lang="en-US"/>
               <a:t>Second level</a:t>
             </a:r>
           </a:p>
           <a:p>
             <a:pPr lvl="2"/>
             <a:r>
-              <a:rPr lang="en-US" smtClean="0"/>
+              <a:rPr lang="en-US"/>
               <a:t>Third level</a:t>
             </a:r>
           </a:p>
           <a:p>
             <a:pPr lvl="3"/>
             <a:r>
-              <a:rPr lang="en-US" smtClean="0"/>
+              <a:rPr lang="en-US"/>
               <a:t>Fourth level</a:t>
             </a:r>
           </a:p>
           <a:p>
             <a:pPr lvl="4"/>
             <a:r>
-              <a:rPr lang="en-US" smtClean="0"/>
+              <a:rPr lang="en-US"/>
               <a:t>Fifth level</a:t>
             </a:r>
-            <a:endParaRPr lang="en-US"/>
           </a:p>
         </p:txBody>
       </p:sp>
@@ -2729,7 +2724,7 @@
           <a:p>
             <a:fld id="{5BCAD085-E8A6-8845-BD4E-CB4CCA059FC4}" type="datetimeFigureOut">
               <a:rPr lang="en-US" smtClean="0"/>
-              <a:t>1/27/13</a:t>
+              <a:t>9/16/2026</a:t>
             </a:fld>
             <a:endParaRPr lang="en-US"/>
           </a:p>
@@ -3088,7 +3083,7 @@
 </file>
 
 <file path=ppt/slides/slide1.xml><?xml version="1.0" encoding="utf-8"?>
-<p:sld xmlns:a="http://schemas.openxmlformats.org/drawingml/2006/main" xmlns:p="http://schemas.openxmlformats.org/presentationml/2006/main" xmlns:r="http://schemas.openxmlformats.org/officeDocument/2006/relationships">
+<p:sld xmlns:a="http://schemas.openxmlformats.org/drawingml/2006/main" xmlns:r="http://schemas.openxmlformats.org/officeDocument/2006/relationships" xmlns:p="http://schemas.openxmlformats.org/presentationml/2006/main">
   <p:cSld>
     <p:spTree>
       <p:nvGrpSpPr>
@@ -3096,7 +3091,14 @@
         <p:cNvGrpSpPr/>
         <p:nvPr/>
       </p:nvGrpSpPr>
-      <p:grpSpPr/>
+      <p:grpSpPr>
+        <a:xfrm>
+          <a:off x="0" y="0"/>
+          <a:ext cx="0" cy="0"/>
+          <a:chOff x="0" y="0"/>
+          <a:chExt cx="0" cy="0"/>
+        </a:xfrm>
+      </p:grpSpPr>
       <p:sp>
         <p:nvSpPr>
           <p:cNvPr id="2" name="Rectangle 1"/>
@@ -3137,6 +3139,7 @@
           <a:lstStyle/>
           <a:p>
             <a:pPr algn="ctr"/>
+            <a:endParaRPr/>
           </a:p>
         </p:txBody>
       </p:sp>
@@ -3182,6 +3185,7 @@
           <a:lstStyle/>
           <a:p>
             <a:pPr algn="ctr"/>
+            <a:endParaRPr/>
           </a:p>
         </p:txBody>
       </p:sp>
@@ -3194,7 +3198,7 @@
         <p:spPr>
           <a:xfrm>
             <a:off x="1371600" y="1371600"/>
-            <a:ext cx="9448495" cy="4114800"/>
+            <a:ext cx="9448495" cy="1826141"/>
           </a:xfrm>
           <a:prstGeom prst="rect">
             <a:avLst/>
@@ -3218,6 +3222,7 @@
               </a:defRPr>
             </a:pPr>
             <a:r>
+              <a:rPr dirty="0"/>
               <a:t>INFOSYS SPRINGBOARD INTERNSHIP PROJECT REPORT</a:t>
             </a:r>
           </a:p>
@@ -3233,10 +3238,18 @@
               </a:defRPr>
             </a:pPr>
             <a:r>
-              <a:t>ClipMind AI: Video Summarization &amp;</a:t>
-            </a:r>
-            <a:br/>
-            <a:r>
+              <a:rPr dirty="0" err="1"/>
+              <a:t>ClipMind</a:t>
+            </a:r>
+            <a:r>
+              <a:rPr dirty="0"/>
+              <a:t> AI: Video Summarization &amp;</a:t>
+            </a:r>
+            <a:br>
+              <a:rPr dirty="0"/>
+            </a:br>
+            <a:r>
+              <a:rPr dirty="0"/>
               <a:t>Key Moments Detection Platform</a:t>
             </a:r>
           </a:p>
@@ -3252,31 +3265,8 @@
               </a:defRPr>
             </a:pPr>
             <a:r>
-              <a:t>Enterprise-Grade Multimodal Video Intelligence with Zero-Loss Google Drive Cloud Storage &amp; Concept Mind Mapping</a:t>
-            </a:r>
-          </a:p>
-          <a:p>
-            <a:pPr>
-              <a:defRPr sz="1300" b="1">
-                <a:solidFill>
-                  <a:srgbClr val="1E3A8A"/>
-                </a:solidFill>
-              </a:defRPr>
-            </a:pPr>
-            <a:r>
-              <a:t>Developer: Adabala Venkata Thrinadh  |  B.Tech Computer Science &amp; Engineering (Batch 2024–2028)</a:t>
-            </a:r>
-          </a:p>
-          <a:p>
-            <a:pPr>
-              <a:defRPr sz="1150">
-                <a:solidFill>
-                  <a:srgbClr val="64748B"/>
-                </a:solidFill>
-              </a:defRPr>
-            </a:pPr>
-            <a:r>
-              <a:t>Institution: GMR Institute of Technology, Rajam  |  Version: 1.0 Production Technical Release</a:t>
+              <a:rPr dirty="0"/>
+              <a:t>Enterprise-Grade Multimodal Video Intelligence &amp; Concept Mind Mapping</a:t>
             </a:r>
           </a:p>
         </p:txBody>
@@ -3317,7 +3307,7 @@
           </a:fontRef>
         </p:style>
         <p:txBody>
-          <a:bodyPr rtlCol="0" anchor="ctr" wrap="square"/>
+          <a:bodyPr wrap="square" rtlCol="0" anchor="ctr"/>
           <a:lstStyle/>
           <a:p>
             <a:pPr algn="ctr">
@@ -3369,7 +3359,7 @@
           </a:fontRef>
         </p:style>
         <p:txBody>
-          <a:bodyPr rtlCol="0" anchor="ctr" wrap="square"/>
+          <a:bodyPr wrap="square" rtlCol="0" anchor="ctr"/>
           <a:lstStyle/>
           <a:p>
             <a:pPr algn="ctr">
@@ -3421,7 +3411,7 @@
           </a:fontRef>
         </p:style>
         <p:txBody>
-          <a:bodyPr rtlCol="0" anchor="ctr" wrap="square"/>
+          <a:bodyPr wrap="square" rtlCol="0" anchor="ctr"/>
           <a:lstStyle/>
           <a:p>
             <a:pPr algn="ctr">
@@ -3473,7 +3463,7 @@
           </a:fontRef>
         </p:style>
         <p:txBody>
-          <a:bodyPr rtlCol="0" anchor="ctr" wrap="square"/>
+          <a:bodyPr wrap="square" rtlCol="0" anchor="ctr"/>
           <a:lstStyle/>
           <a:p>
             <a:pPr algn="ctr">
@@ -3525,7 +3515,7 @@
           </a:fontRef>
         </p:style>
         <p:txBody>
-          <a:bodyPr rtlCol="0" anchor="ctr" wrap="square"/>
+          <a:bodyPr wrap="square" rtlCol="0" anchor="ctr"/>
           <a:lstStyle/>
           <a:p>
             <a:pPr algn="ctr">
@@ -3550,7 +3540,7 @@
 </file>
 
 <file path=ppt/slides/slide10.xml><?xml version="1.0" encoding="utf-8"?>
-<p:sld xmlns:a="http://schemas.openxmlformats.org/drawingml/2006/main" xmlns:p="http://schemas.openxmlformats.org/presentationml/2006/main" xmlns:r="http://schemas.openxmlformats.org/officeDocument/2006/relationships">
+<p:sld xmlns:a="http://schemas.openxmlformats.org/drawingml/2006/main" xmlns:r="http://schemas.openxmlformats.org/officeDocument/2006/relationships" xmlns:p="http://schemas.openxmlformats.org/presentationml/2006/main">
   <p:cSld>
     <p:spTree>
       <p:nvGrpSpPr>
@@ -3558,7 +3548,14 @@
         <p:cNvGrpSpPr/>
         <p:nvPr/>
       </p:nvGrpSpPr>
-      <p:grpSpPr/>
+      <p:grpSpPr>
+        <a:xfrm>
+          <a:off x="0" y="0"/>
+          <a:ext cx="0" cy="0"/>
+          <a:chOff x="0" y="0"/>
+          <a:chExt cx="0" cy="0"/>
+        </a:xfrm>
+      </p:grpSpPr>
       <p:sp>
         <p:nvSpPr>
           <p:cNvPr id="2" name="Rectangle 1"/>
@@ -3599,6 +3596,7 @@
           <a:lstStyle/>
           <a:p>
             <a:pPr algn="ctr"/>
+            <a:endParaRPr sz="2400"/>
           </a:p>
         </p:txBody>
       </p:sp>
@@ -3611,7 +3609,7 @@
         <p:spPr>
           <a:xfrm>
             <a:off x="731520" y="365760"/>
-            <a:ext cx="10515600" cy="320040"/>
+            <a:ext cx="10515600" cy="261610"/>
           </a:xfrm>
           <a:prstGeom prst="rect">
             <a:avLst/>
@@ -3632,6 +3630,7 @@
               </a:defRPr>
             </a:pPr>
             <a:r>
+              <a:rPr sz="1100"/>
               <a:t>INFOSYS SPRINGBOARD • AI &amp; FULL-STACK CLOUD INTERNSHIP</a:t>
             </a:r>
           </a:p>
@@ -3646,7 +3645,7 @@
         <p:spPr>
           <a:xfrm>
             <a:off x="731520" y="640080"/>
-            <a:ext cx="10515600" cy="640080"/>
+            <a:ext cx="10515600" cy="523220"/>
           </a:xfrm>
           <a:prstGeom prst="rect">
             <a:avLst/>
@@ -3667,6 +3666,7 @@
               </a:defRPr>
             </a:pPr>
             <a:r>
+              <a:rPr sz="2800"/>
               <a:t>9. Conclusion, Technical Stack &amp; Operational Readiness</a:t>
             </a:r>
           </a:p>
@@ -3712,6 +3712,7 @@
           <a:lstStyle/>
           <a:p>
             <a:pPr algn="ctr"/>
+            <a:endParaRPr sz="2400"/>
           </a:p>
         </p:txBody>
       </p:sp>
@@ -3757,6 +3758,7 @@
           <a:lstStyle/>
           <a:p>
             <a:pPr algn="ctr"/>
+            <a:endParaRPr sz="2400"/>
           </a:p>
         </p:txBody>
       </p:sp>
@@ -3769,7 +3771,7 @@
         <p:spPr>
           <a:xfrm>
             <a:off x="914400" y="1645920"/>
-            <a:ext cx="4663440" cy="4480560"/>
+            <a:ext cx="4663440" cy="3590727"/>
           </a:xfrm>
           <a:prstGeom prst="rect">
             <a:avLst/>
@@ -3808,6 +3810,7 @@
               </a:defRPr>
             </a:pPr>
             <a:r>
+              <a:rPr sz="1400"/>
               <a:t>- 100% Compliance with Infosys Springboard Project Specification.</a:t>
             </a:r>
           </a:p>
@@ -3823,6 +3826,7 @@
               </a:defRPr>
             </a:pPr>
             <a:r>
+              <a:rPr sz="1400"/>
               <a:t>- Production-Grade Full-Stack: React 19 + FastAPI + Polyglot DB.</a:t>
             </a:r>
           </a:p>
@@ -3838,6 +3842,7 @@
               </a:defRPr>
             </a:pPr>
             <a:r>
+              <a:rPr sz="1400"/>
               <a:t>- Zero-Loss Cloud: 15GB persistent Google Drive storage with HTTP 206 range proxy.</a:t>
             </a:r>
           </a:p>
@@ -3853,6 +3858,7 @@
               </a:defRPr>
             </a:pPr>
             <a:r>
+              <a:rPr sz="1400"/>
               <a:t>- Multimodal AI: Whisper STT, LexRank + LLMs, OpenCV scene cut detection.</a:t>
             </a:r>
           </a:p>
@@ -3868,6 +3874,7 @@
               </a:defRPr>
             </a:pPr>
             <a:r>
+              <a:rPr sz="1400"/>
               <a:t>- Bespoke UI Design: Human-crafted dark/light engineering UI with zero AI-generic vibe.</a:t>
             </a:r>
           </a:p>
@@ -3883,6 +3890,7 @@
               </a:defRPr>
             </a:pPr>
             <a:r>
+              <a:rPr sz="1400"/>
               <a:t>- Unified Docker Containerization: Tested &amp; ready for production deployment.</a:t>
             </a:r>
           </a:p>
@@ -3930,6 +3938,7 @@
           <a:lstStyle/>
           <a:p>
             <a:pPr algn="ctr"/>
+            <a:endParaRPr sz="2400"/>
           </a:p>
         </p:txBody>
       </p:sp>
@@ -3942,7 +3951,7 @@
         <p:spPr>
           <a:xfrm>
             <a:off x="6583680" y="1645920"/>
-            <a:ext cx="4663440" cy="4480560"/>
+            <a:ext cx="4663440" cy="2718693"/>
           </a:xfrm>
           <a:prstGeom prst="rect">
             <a:avLst/>
@@ -3974,17 +3983,18 @@
               <a:spcAft>
                 <a:spcPts val="400"/>
               </a:spcAft>
-              <a:defRPr b="1" sz="1050">
+              <a:defRPr sz="1050" b="1">
                 <a:solidFill>
                   <a:srgbClr val="1E3A8A"/>
                 </a:solidFill>
               </a:defRPr>
             </a:pPr>
             <a:r>
+              <a:rPr sz="1200"/>
               <a:t>• Frontend Client: </a:t>
             </a:r>
             <a:r>
-              <a:rPr b="0" sz="1000">
+              <a:rPr sz="1100" b="0">
                 <a:solidFill>
                   <a:srgbClr val="64748B"/>
                 </a:solidFill>
@@ -3997,17 +4007,18 @@
               <a:spcAft>
                 <a:spcPts val="400"/>
               </a:spcAft>
-              <a:defRPr b="1" sz="1050">
+              <a:defRPr sz="1050" b="1">
                 <a:solidFill>
                   <a:srgbClr val="1E3A8A"/>
                 </a:solidFill>
               </a:defRPr>
             </a:pPr>
             <a:r>
+              <a:rPr sz="1200"/>
               <a:t>• API Gateway: </a:t>
             </a:r>
             <a:r>
-              <a:rPr b="0" sz="1000">
+              <a:rPr sz="1100" b="0">
                 <a:solidFill>
                   <a:srgbClr val="64748B"/>
                 </a:solidFill>
@@ -4020,17 +4031,18 @@
               <a:spcAft>
                 <a:spcPts val="400"/>
               </a:spcAft>
-              <a:defRPr b="1" sz="1050">
+              <a:defRPr sz="1050" b="1">
                 <a:solidFill>
                   <a:srgbClr val="1E3A8A"/>
                 </a:solidFill>
               </a:defRPr>
             </a:pPr>
             <a:r>
+              <a:rPr sz="1200"/>
               <a:t>• Auth &amp; Security: </a:t>
             </a:r>
             <a:r>
-              <a:rPr b="0" sz="1000">
+              <a:rPr sz="1100" b="0">
                 <a:solidFill>
                   <a:srgbClr val="64748B"/>
                 </a:solidFill>
@@ -4043,17 +4055,18 @@
               <a:spcAft>
                 <a:spcPts val="400"/>
               </a:spcAft>
-              <a:defRPr b="1" sz="1050">
+              <a:defRPr sz="1050" b="1">
                 <a:solidFill>
                   <a:srgbClr val="1E3A8A"/>
                 </a:solidFill>
               </a:defRPr>
             </a:pPr>
             <a:r>
+              <a:rPr sz="1200"/>
               <a:t>• Polyglot Database: </a:t>
             </a:r>
             <a:r>
-              <a:rPr b="0" sz="1000">
+              <a:rPr sz="1100" b="0">
                 <a:solidFill>
                   <a:srgbClr val="64748B"/>
                 </a:solidFill>
@@ -4066,17 +4079,18 @@
               <a:spcAft>
                 <a:spcPts val="400"/>
               </a:spcAft>
-              <a:defRPr b="1" sz="1050">
+              <a:defRPr sz="1050" b="1">
                 <a:solidFill>
                   <a:srgbClr val="1E3A8A"/>
                 </a:solidFill>
               </a:defRPr>
             </a:pPr>
             <a:r>
+              <a:rPr sz="1200"/>
               <a:t>• Cloud Storage: </a:t>
             </a:r>
             <a:r>
-              <a:rPr b="0" sz="1000">
+              <a:rPr sz="1100" b="0">
                 <a:solidFill>
                   <a:srgbClr val="64748B"/>
                 </a:solidFill>
@@ -4089,17 +4103,18 @@
               <a:spcAft>
                 <a:spcPts val="400"/>
               </a:spcAft>
-              <a:defRPr b="1" sz="1050">
+              <a:defRPr sz="1050" b="1">
                 <a:solidFill>
                   <a:srgbClr val="1E3A8A"/>
                 </a:solidFill>
               </a:defRPr>
             </a:pPr>
             <a:r>
+              <a:rPr sz="1200"/>
               <a:t>• AI &amp; CV Models: </a:t>
             </a:r>
             <a:r>
-              <a:rPr b="0" sz="1000">
+              <a:rPr sz="1100" b="0">
                 <a:solidFill>
                   <a:srgbClr val="64748B"/>
                 </a:solidFill>
@@ -4112,17 +4127,18 @@
               <a:spcAft>
                 <a:spcPts val="400"/>
               </a:spcAft>
-              <a:defRPr b="1" sz="1050">
+              <a:defRPr sz="1050" b="1">
                 <a:solidFill>
                   <a:srgbClr val="1E3A8A"/>
                 </a:solidFill>
               </a:defRPr>
             </a:pPr>
             <a:r>
+              <a:rPr sz="1200"/>
               <a:t>• Media Extraction: </a:t>
             </a:r>
             <a:r>
-              <a:rPr b="0" sz="1000">
+              <a:rPr sz="1100" b="0">
                 <a:solidFill>
                   <a:srgbClr val="64748B"/>
                 </a:solidFill>
@@ -4135,17 +4151,18 @@
               <a:spcAft>
                 <a:spcPts val="400"/>
               </a:spcAft>
-              <a:defRPr b="1" sz="1050">
+              <a:defRPr sz="1050" b="1">
                 <a:solidFill>
                   <a:srgbClr val="1E3A8A"/>
                 </a:solidFill>
               </a:defRPr>
             </a:pPr>
             <a:r>
+              <a:rPr sz="1200"/>
               <a:t>• Document Exports: </a:t>
             </a:r>
             <a:r>
-              <a:rPr b="0" sz="1000">
+              <a:rPr sz="1100" b="0">
                 <a:solidFill>
                   <a:srgbClr val="64748B"/>
                 </a:solidFill>
@@ -4158,17 +4175,18 @@
               <a:spcAft>
                 <a:spcPts val="400"/>
               </a:spcAft>
-              <a:defRPr b="1" sz="1050">
+              <a:defRPr sz="1050" b="1">
                 <a:solidFill>
                   <a:srgbClr val="1E3A8A"/>
                 </a:solidFill>
               </a:defRPr>
             </a:pPr>
             <a:r>
+              <a:rPr sz="1200"/>
               <a:t>• DevOps / Deploy: </a:t>
             </a:r>
             <a:r>
-              <a:rPr b="0" sz="1000">
+              <a:rPr sz="1100" b="0">
                 <a:solidFill>
                   <a:srgbClr val="64748B"/>
                 </a:solidFill>
@@ -4187,7 +4205,7 @@
 </file>
 
 <file path=ppt/slides/slide2.xml><?xml version="1.0" encoding="utf-8"?>
-<p:sld xmlns:a="http://schemas.openxmlformats.org/drawingml/2006/main" xmlns:p="http://schemas.openxmlformats.org/presentationml/2006/main" xmlns:r="http://schemas.openxmlformats.org/officeDocument/2006/relationships">
+<p:sld xmlns:a="http://schemas.openxmlformats.org/drawingml/2006/main" xmlns:r="http://schemas.openxmlformats.org/officeDocument/2006/relationships" xmlns:p="http://schemas.openxmlformats.org/presentationml/2006/main">
   <p:cSld>
     <p:spTree>
       <p:nvGrpSpPr>
@@ -4195,7 +4213,14 @@
         <p:cNvGrpSpPr/>
         <p:nvPr/>
       </p:nvGrpSpPr>
-      <p:grpSpPr/>
+      <p:grpSpPr>
+        <a:xfrm>
+          <a:off x="0" y="0"/>
+          <a:ext cx="0" cy="0"/>
+          <a:chOff x="0" y="0"/>
+          <a:chExt cx="0" cy="0"/>
+        </a:xfrm>
+      </p:grpSpPr>
       <p:sp>
         <p:nvSpPr>
           <p:cNvPr id="2" name="Rectangle 1"/>
@@ -4236,6 +4261,7 @@
           <a:lstStyle/>
           <a:p>
             <a:pPr algn="ctr"/>
+            <a:endParaRPr/>
           </a:p>
         </p:txBody>
       </p:sp>
@@ -4349,6 +4375,7 @@
           <a:lstStyle/>
           <a:p>
             <a:pPr algn="ctr"/>
+            <a:endParaRPr/>
           </a:p>
         </p:txBody>
       </p:sp>
@@ -4394,6 +4421,7 @@
           <a:lstStyle/>
           <a:p>
             <a:pPr algn="ctr"/>
+            <a:endParaRPr/>
           </a:p>
         </p:txBody>
       </p:sp>
@@ -4405,8 +4433,8 @@
         </p:nvSpPr>
         <p:spPr>
           <a:xfrm>
-            <a:off x="914400" y="1645920"/>
-            <a:ext cx="4572000" cy="4480560"/>
+            <a:off x="914399" y="1645919"/>
+            <a:ext cx="4645479" cy="4001095"/>
           </a:xfrm>
           <a:prstGeom prst="rect">
             <a:avLst/>
@@ -4430,6 +4458,7 @@
               </a:defRPr>
             </a:pPr>
             <a:r>
+              <a:rPr dirty="0"/>
               <a:t>Traditional Video Learning Bottlenecks</a:t>
             </a:r>
           </a:p>
@@ -4438,17 +4467,18 @@
               <a:spcAft>
                 <a:spcPts val="800"/>
               </a:spcAft>
-              <a:defRPr b="1" sz="1100">
+              <a:defRPr sz="1100" b="1">
                 <a:solidFill>
                   <a:srgbClr val="1E293B"/>
                 </a:solidFill>
               </a:defRPr>
             </a:pPr>
             <a:r>
+              <a:rPr sz="1200" dirty="0"/>
               <a:t>• Linear Scrubbing Friction: </a:t>
             </a:r>
             <a:r>
-              <a:rPr b="0" sz="1000">
+              <a:rPr sz="1600" b="0" dirty="0">
                 <a:solidFill>
                   <a:srgbClr val="64748B"/>
                 </a:solidFill>
@@ -4461,17 +4491,18 @@
               <a:spcAft>
                 <a:spcPts val="800"/>
               </a:spcAft>
-              <a:defRPr b="1" sz="1100">
+              <a:defRPr sz="1100" b="1">
                 <a:solidFill>
                   <a:srgbClr val="1E293B"/>
                 </a:solidFill>
               </a:defRPr>
             </a:pPr>
             <a:r>
+              <a:rPr sz="1200" dirty="0"/>
               <a:t>• Zero In-Video Semantic Search: </a:t>
             </a:r>
             <a:r>
-              <a:rPr b="0" sz="1000">
+              <a:rPr sz="1600" b="0" dirty="0">
                 <a:solidFill>
                   <a:srgbClr val="64748B"/>
                 </a:solidFill>
@@ -4484,17 +4515,18 @@
               <a:spcAft>
                 <a:spcPts val="800"/>
               </a:spcAft>
-              <a:defRPr b="1" sz="1100">
+              <a:defRPr sz="1100" b="1">
                 <a:solidFill>
                   <a:srgbClr val="1E293B"/>
                 </a:solidFill>
               </a:defRPr>
             </a:pPr>
             <a:r>
+              <a:rPr sz="1200" dirty="0"/>
               <a:t>• Ephemeral Cloud Media Loss: </a:t>
             </a:r>
             <a:r>
-              <a:rPr b="0" sz="1000">
+              <a:rPr sz="1600" b="0" dirty="0">
                 <a:solidFill>
                   <a:srgbClr val="64748B"/>
                 </a:solidFill>
@@ -4507,17 +4539,18 @@
               <a:spcAft>
                 <a:spcPts val="800"/>
               </a:spcAft>
-              <a:defRPr b="1" sz="1100">
+              <a:defRPr sz="1100" b="1">
                 <a:solidFill>
                   <a:srgbClr val="1E293B"/>
                 </a:solidFill>
               </a:defRPr>
             </a:pPr>
             <a:r>
+              <a:rPr sz="1200" dirty="0"/>
               <a:t>• Passive Cognitive Decay: </a:t>
             </a:r>
             <a:r>
-              <a:rPr b="0" sz="1000">
+              <a:rPr sz="1600" b="0" dirty="0">
                 <a:solidFill>
                   <a:srgbClr val="64748B"/>
                 </a:solidFill>
@@ -4567,6 +4600,7 @@
           <a:lstStyle/>
           <a:p>
             <a:pPr algn="ctr"/>
+            <a:endParaRPr/>
           </a:p>
         </p:txBody>
       </p:sp>
@@ -4612,6 +4646,7 @@
           <a:lstStyle/>
           <a:p>
             <a:pPr algn="ctr"/>
+            <a:endParaRPr/>
           </a:p>
         </p:txBody>
       </p:sp>
@@ -4624,7 +4659,7 @@
         <p:spPr>
           <a:xfrm>
             <a:off x="6675120" y="1645920"/>
-            <a:ext cx="4572000" cy="4480560"/>
+            <a:ext cx="4572000" cy="4001095"/>
           </a:xfrm>
           <a:prstGeom prst="rect">
             <a:avLst/>
@@ -4648,7 +4683,12 @@
               </a:defRPr>
             </a:pPr>
             <a:r>
-              <a:t>ClipMind AI Cognitive Solution</a:t>
+              <a:rPr dirty="0" err="1"/>
+              <a:t>ClipMind</a:t>
+            </a:r>
+            <a:r>
+              <a:rPr dirty="0"/>
+              <a:t> AI Cognitive Solution</a:t>
             </a:r>
           </a:p>
           <a:p>
@@ -4656,17 +4696,18 @@
               <a:spcAft>
                 <a:spcPts val="800"/>
               </a:spcAft>
-              <a:defRPr b="1" sz="1100">
+              <a:defRPr sz="1100" b="1">
                 <a:solidFill>
                   <a:srgbClr val="1E293B"/>
                 </a:solidFill>
               </a:defRPr>
             </a:pPr>
             <a:r>
+              <a:rPr sz="1200" dirty="0"/>
               <a:t>• Sub-Second Word-Level Seeking: </a:t>
             </a:r>
             <a:r>
-              <a:rPr b="0" sz="1000">
+              <a:rPr sz="1600" b="0" dirty="0">
                 <a:solidFill>
                   <a:srgbClr val="64748B"/>
                 </a:solidFill>
@@ -4679,22 +4720,31 @@
               <a:spcAft>
                 <a:spcPts val="800"/>
               </a:spcAft>
-              <a:defRPr b="1" sz="1100">
+              <a:defRPr sz="1100" b="1">
                 <a:solidFill>
                   <a:srgbClr val="1E293B"/>
                 </a:solidFill>
               </a:defRPr>
             </a:pPr>
             <a:r>
+              <a:rPr sz="1200" dirty="0"/>
               <a:t>• Dual-Tier Summaries &amp; Mind Maps: </a:t>
             </a:r>
             <a:r>
-              <a:rPr b="0" sz="1000">
+              <a:rPr sz="1600" b="0" dirty="0" err="1">
                 <a:solidFill>
                   <a:srgbClr val="64748B"/>
                 </a:solidFill>
               </a:rPr>
-              <a:t>LexRank graph centrality + LLM chapter synthesis + interactive SVG concept graph for visual hierarchical learning.</a:t>
+              <a:t>LexRank</a:t>
+            </a:r>
+            <a:r>
+              <a:rPr sz="1600" b="0" dirty="0">
+                <a:solidFill>
+                  <a:srgbClr val="64748B"/>
+                </a:solidFill>
+              </a:rPr>
+              <a:t> graph centrality + LLM chapter synthesis + interactive SVG concept graph for visual hierarchical learning.</a:t>
             </a:r>
           </a:p>
           <a:p>
@@ -4702,17 +4752,18 @@
               <a:spcAft>
                 <a:spcPts val="800"/>
               </a:spcAft>
-              <a:defRPr b="1" sz="1100">
+              <a:defRPr sz="1100" b="1">
                 <a:solidFill>
                   <a:srgbClr val="1E293B"/>
                 </a:solidFill>
               </a:defRPr>
             </a:pPr>
             <a:r>
+              <a:rPr sz="1200" dirty="0"/>
               <a:t>• Google Drive 15GB Cloud Storage: </a:t>
             </a:r>
             <a:r>
-              <a:rPr b="0" sz="1000">
+              <a:rPr sz="1600" b="0" dirty="0">
                 <a:solidFill>
                   <a:srgbClr val="64748B"/>
                 </a:solidFill>
@@ -4725,17 +4776,18 @@
               <a:spcAft>
                 <a:spcPts val="800"/>
               </a:spcAft>
-              <a:defRPr b="1" sz="1100">
+              <a:defRPr sz="1100" b="1">
                 <a:solidFill>
                   <a:srgbClr val="1E293B"/>
                 </a:solidFill>
               </a:defRPr>
             </a:pPr>
             <a:r>
+              <a:rPr sz="1200" dirty="0"/>
               <a:t>• Active Recall &amp; Spaced Repetition: </a:t>
             </a:r>
             <a:r>
-              <a:rPr b="0" sz="1000">
+              <a:rPr sz="1600" b="0" dirty="0">
                 <a:solidFill>
                   <a:srgbClr val="64748B"/>
                 </a:solidFill>
@@ -4754,7 +4806,7 @@
 </file>
 
 <file path=ppt/slides/slide3.xml><?xml version="1.0" encoding="utf-8"?>
-<p:sld xmlns:a="http://schemas.openxmlformats.org/drawingml/2006/main" xmlns:p="http://schemas.openxmlformats.org/presentationml/2006/main" xmlns:r="http://schemas.openxmlformats.org/officeDocument/2006/relationships">
+<p:sld xmlns:a="http://schemas.openxmlformats.org/drawingml/2006/main" xmlns:r="http://schemas.openxmlformats.org/officeDocument/2006/relationships" xmlns:p="http://schemas.openxmlformats.org/presentationml/2006/main">
   <p:cSld>
     <p:spTree>
       <p:nvGrpSpPr>
@@ -4762,7 +4814,14 @@
         <p:cNvGrpSpPr/>
         <p:nvPr/>
       </p:nvGrpSpPr>
-      <p:grpSpPr/>
+      <p:grpSpPr>
+        <a:xfrm>
+          <a:off x="0" y="0"/>
+          <a:ext cx="0" cy="0"/>
+          <a:chOff x="0" y="0"/>
+          <a:chExt cx="0" cy="0"/>
+        </a:xfrm>
+      </p:grpSpPr>
       <p:sp>
         <p:nvSpPr>
           <p:cNvPr id="2" name="Rectangle 1"/>
@@ -4803,6 +4862,7 @@
           <a:lstStyle/>
           <a:p>
             <a:pPr algn="ctr"/>
+            <a:endParaRPr sz="2400"/>
           </a:p>
         </p:txBody>
       </p:sp>
@@ -4815,7 +4875,7 @@
         <p:spPr>
           <a:xfrm>
             <a:off x="731520" y="365760"/>
-            <a:ext cx="10515600" cy="320040"/>
+            <a:ext cx="10515600" cy="261610"/>
           </a:xfrm>
           <a:prstGeom prst="rect">
             <a:avLst/>
@@ -4836,6 +4896,7 @@
               </a:defRPr>
             </a:pPr>
             <a:r>
+              <a:rPr sz="1100"/>
               <a:t>INFOSYS SPRINGBOARD • AI &amp; FULL-STACK CLOUD INTERNSHIP</a:t>
             </a:r>
           </a:p>
@@ -4850,7 +4911,7 @@
         <p:spPr>
           <a:xfrm>
             <a:off x="731520" y="640080"/>
-            <a:ext cx="10515600" cy="640080"/>
+            <a:ext cx="10515600" cy="523220"/>
           </a:xfrm>
           <a:prstGeom prst="rect">
             <a:avLst/>
@@ -4871,6 +4932,7 @@
               </a:defRPr>
             </a:pPr>
             <a:r>
+              <a:rPr sz="2800"/>
               <a:t>2. Proposed Solution &amp; Novelty (6 Architectural Pillars)</a:t>
             </a:r>
           </a:p>
@@ -4916,6 +4978,7 @@
           <a:lstStyle/>
           <a:p>
             <a:pPr algn="ctr"/>
+            <a:endParaRPr sz="2400"/>
           </a:p>
         </p:txBody>
       </p:sp>
@@ -4961,6 +5024,7 @@
           <a:lstStyle/>
           <a:p>
             <a:pPr algn="ctr"/>
+            <a:endParaRPr sz="2400"/>
           </a:p>
         </p:txBody>
       </p:sp>
@@ -5000,7 +5064,7 @@
           </a:fontRef>
         </p:style>
         <p:txBody>
-          <a:bodyPr rtlCol="0" anchor="ctr" wrap="square"/>
+          <a:bodyPr wrap="square" rtlCol="0" anchor="ctr"/>
           <a:lstStyle/>
           <a:p>
             <a:pPr algn="ctr">
@@ -5011,6 +5075,7 @@
               </a:defRPr>
             </a:pPr>
             <a:r>
+              <a:rPr sz="1000"/>
               <a:t>ZERO-LOSS STORAGE</a:t>
             </a:r>
           </a:p>
@@ -5025,7 +5090,7 @@
         <p:spPr>
           <a:xfrm>
             <a:off x="868680" y="1901952"/>
-            <a:ext cx="3063240" cy="1783080"/>
+            <a:ext cx="3063240" cy="1759456"/>
           </a:xfrm>
           <a:prstGeom prst="rect">
             <a:avLst/>
@@ -5049,6 +5114,7 @@
               </a:defRPr>
             </a:pPr>
             <a:r>
+              <a:rPr sz="1600"/>
               <a:t>Google Drive 15GB Cloud</a:t>
             </a:r>
           </a:p>
@@ -5064,6 +5130,7 @@
               </a:defRPr>
             </a:pPr>
             <a:r>
+              <a:rPr sz="1050"/>
               <a:t>• Direct GIS OAuth 2.0 connection gives 15 GB persistent storage.</a:t>
             </a:r>
           </a:p>
@@ -5079,6 +5146,7 @@
               </a:defRPr>
             </a:pPr>
             <a:r>
+              <a:rPr sz="1050"/>
               <a:t>• Automatic background cloud sync on upload without manual toggle.</a:t>
             </a:r>
           </a:p>
@@ -5094,6 +5162,7 @@
               </a:defRPr>
             </a:pPr>
             <a:r>
+              <a:rPr sz="1050"/>
               <a:t>• HTTP 206 Partial Content range proxy enables sub-20ms seeking.</a:t>
             </a:r>
           </a:p>
@@ -5109,6 +5178,7 @@
               </a:defRPr>
             </a:pPr>
             <a:r>
+              <a:rPr sz="1050"/>
               <a:t>• Eliminates media loss when ephemeral cloud containers reset.</a:t>
             </a:r>
           </a:p>
@@ -5156,6 +5226,7 @@
           <a:lstStyle/>
           <a:p>
             <a:pPr algn="ctr"/>
+            <a:endParaRPr sz="2400"/>
           </a:p>
         </p:txBody>
       </p:sp>
@@ -5195,7 +5266,7 @@
           </a:fontRef>
         </p:style>
         <p:txBody>
-          <a:bodyPr rtlCol="0" anchor="ctr" wrap="square"/>
+          <a:bodyPr wrap="square" rtlCol="0" anchor="ctr"/>
           <a:lstStyle/>
           <a:p>
             <a:pPr algn="ctr">
@@ -5206,6 +5277,7 @@
               </a:defRPr>
             </a:pPr>
             <a:r>
+              <a:rPr sz="1000"/>
               <a:t>RELIABILITY</a:t>
             </a:r>
           </a:p>
@@ -5220,7 +5292,7 @@
         <p:spPr>
           <a:xfrm>
             <a:off x="4553712" y="1901952"/>
-            <a:ext cx="3063240" cy="1783080"/>
+            <a:ext cx="3063240" cy="1759456"/>
           </a:xfrm>
           <a:prstGeom prst="rect">
             <a:avLst/>
@@ -5244,6 +5316,7 @@
               </a:defRPr>
             </a:pPr>
             <a:r>
+              <a:rPr sz="1600"/>
               <a:t>Universal Pipeline Fallback</a:t>
             </a:r>
           </a:p>
@@ -5259,6 +5332,7 @@
               </a:defRPr>
             </a:pPr>
             <a:r>
+              <a:rPr sz="1050"/>
               <a:t>• Pipeline downloads file from Drive if local disk was wiped.</a:t>
             </a:r>
           </a:p>
@@ -5274,6 +5348,7 @@
               </a:defRPr>
             </a:pPr>
             <a:r>
+              <a:rPr sz="1050"/>
               <a:t>• Executes full 7 stages: demux, Whisper ASR, OpenCV, summaries.</a:t>
             </a:r>
           </a:p>
@@ -5289,6 +5364,7 @@
               </a:defRPr>
             </a:pPr>
             <a:r>
+              <a:rPr sz="1050"/>
               <a:t>• 100% processing continuity across restarts and redeployments.</a:t>
             </a:r>
           </a:p>
@@ -5304,6 +5380,7 @@
               </a:defRPr>
             </a:pPr>
             <a:r>
+              <a:rPr sz="1050"/>
               <a:t>• Working disk buffer cleans temporary files automatically.</a:t>
             </a:r>
           </a:p>
@@ -5351,6 +5428,7 @@
           <a:lstStyle/>
           <a:p>
             <a:pPr algn="ctr"/>
+            <a:endParaRPr sz="2400"/>
           </a:p>
         </p:txBody>
       </p:sp>
@@ -5390,7 +5468,7 @@
           </a:fontRef>
         </p:style>
         <p:txBody>
-          <a:bodyPr rtlCol="0" anchor="ctr" wrap="square"/>
+          <a:bodyPr wrap="square" rtlCol="0" anchor="ctr"/>
           <a:lstStyle/>
           <a:p>
             <a:pPr algn="ctr">
@@ -5401,6 +5479,7 @@
               </a:defRPr>
             </a:pPr>
             <a:r>
+              <a:rPr sz="1000"/>
               <a:t>KNOWLEDGE GRAPH</a:t>
             </a:r>
           </a:p>
@@ -5415,7 +5494,7 @@
         <p:spPr>
           <a:xfrm>
             <a:off x="8238744" y="1901952"/>
-            <a:ext cx="3063240" cy="1783080"/>
+            <a:ext cx="3063240" cy="1759456"/>
           </a:xfrm>
           <a:prstGeom prst="rect">
             <a:avLst/>
@@ -5439,6 +5518,7 @@
               </a:defRPr>
             </a:pPr>
             <a:r>
+              <a:rPr sz="1600"/>
               <a:t>Interactive Concept Mind Maps</a:t>
             </a:r>
           </a:p>
@@ -5454,6 +5534,7 @@
               </a:defRPr>
             </a:pPr>
             <a:r>
+              <a:rPr sz="1050"/>
               <a:t>• Synthesizes transcript into hierarchical conceptual tree.</a:t>
             </a:r>
           </a:p>
@@ -5469,6 +5550,7 @@
               </a:defRPr>
             </a:pPr>
             <a:r>
+              <a:rPr sz="1050"/>
               <a:t>• Clicking any node seeks video player immediately to timestamp.</a:t>
             </a:r>
           </a:p>
@@ -5484,6 +5566,7 @@
               </a:defRPr>
             </a:pPr>
             <a:r>
+              <a:rPr sz="1050"/>
               <a:t>• Dynamic SVG canvas with smooth drag-to-pan, zoom, and search.</a:t>
             </a:r>
           </a:p>
@@ -5499,6 +5582,7 @@
               </a:defRPr>
             </a:pPr>
             <a:r>
+              <a:rPr sz="1050"/>
               <a:t>• 1-click export generates publication-grade vector SVG study notes.</a:t>
             </a:r>
           </a:p>
@@ -5546,6 +5630,7 @@
           <a:lstStyle/>
           <a:p>
             <a:pPr algn="ctr"/>
+            <a:endParaRPr sz="2400"/>
           </a:p>
         </p:txBody>
       </p:sp>
@@ -5585,7 +5670,7 @@
           </a:fontRef>
         </p:style>
         <p:txBody>
-          <a:bodyPr rtlCol="0" anchor="ctr" wrap="square"/>
+          <a:bodyPr wrap="square" rtlCol="0" anchor="ctr"/>
           <a:lstStyle/>
           <a:p>
             <a:pPr algn="ctr">
@@ -5596,6 +5681,7 @@
               </a:defRPr>
             </a:pPr>
             <a:r>
+              <a:rPr sz="1000"/>
               <a:t>WHISPER &amp; OPENCV</a:t>
             </a:r>
           </a:p>
@@ -5610,7 +5696,7 @@
         <p:spPr>
           <a:xfrm>
             <a:off x="868680" y="4462272"/>
-            <a:ext cx="3063240" cy="1783080"/>
+            <a:ext cx="3063240" cy="1759456"/>
           </a:xfrm>
           <a:prstGeom prst="rect">
             <a:avLst/>
@@ -5634,6 +5720,7 @@
               </a:defRPr>
             </a:pPr>
             <a:r>
+              <a:rPr sz="1600"/>
               <a:t>Multimodal Video Engine</a:t>
             </a:r>
           </a:p>
@@ -5649,6 +5736,7 @@
               </a:defRPr>
             </a:pPr>
             <a:r>
+              <a:rPr sz="1050"/>
               <a:t>• OpenAI Whisper ASR achieves 4.18% WER (95.82% accuracy).</a:t>
             </a:r>
           </a:p>
@@ -5664,6 +5752,7 @@
               </a:defRPr>
             </a:pPr>
             <a:r>
+              <a:rPr sz="1050"/>
               <a:t>• Sub-second word-level timestamp alignment with auto-scroll.</a:t>
             </a:r>
           </a:p>
@@ -5679,6 +5768,7 @@
               </a:defRPr>
             </a:pPr>
             <a:r>
+              <a:rPr sz="1050"/>
               <a:t>• OpenCV 1 fps frame deltas and HSV histograms detect slide cuts.</a:t>
             </a:r>
           </a:p>
@@ -5694,6 +5784,7 @@
               </a:defRPr>
             </a:pPr>
             <a:r>
+              <a:rPr sz="1050"/>
               <a:t>• Correlates visual transitions with spoken sentence boundaries.</a:t>
             </a:r>
           </a:p>
@@ -5741,6 +5832,7 @@
           <a:lstStyle/>
           <a:p>
             <a:pPr algn="ctr"/>
+            <a:endParaRPr sz="2400"/>
           </a:p>
         </p:txBody>
       </p:sp>
@@ -5780,7 +5872,7 @@
           </a:fontRef>
         </p:style>
         <p:txBody>
-          <a:bodyPr rtlCol="0" anchor="ctr" wrap="square"/>
+          <a:bodyPr wrap="square" rtlCol="0" anchor="ctr"/>
           <a:lstStyle/>
           <a:p>
             <a:pPr algn="ctr">
@@ -5791,6 +5883,7 @@
               </a:defRPr>
             </a:pPr>
             <a:r>
+              <a:rPr sz="1000"/>
               <a:t>EXTRACTIVE &amp; ABSTRACTIVE</a:t>
             </a:r>
           </a:p>
@@ -5805,7 +5898,7 @@
         <p:spPr>
           <a:xfrm>
             <a:off x="4553712" y="4462272"/>
-            <a:ext cx="3063240" cy="1783080"/>
+            <a:ext cx="3063240" cy="1759456"/>
           </a:xfrm>
           <a:prstGeom prst="rect">
             <a:avLst/>
@@ -5829,6 +5922,7 @@
               </a:defRPr>
             </a:pPr>
             <a:r>
+              <a:rPr sz="1600"/>
               <a:t>Dual-Tier Summarization</a:t>
             </a:r>
           </a:p>
@@ -5844,6 +5938,7 @@
               </a:defRPr>
             </a:pPr>
             <a:r>
+              <a:rPr sz="1050"/>
               <a:t>• Tier 1: LexRank TF-IDF graph centrality extracts TL;DR in &lt;1.5s.</a:t>
             </a:r>
           </a:p>
@@ -5859,6 +5954,7 @@
               </a:defRPr>
             </a:pPr>
             <a:r>
+              <a:rPr sz="1050"/>
               <a:t>• Tier 2: Generative LLMs synthesize modular curriculum chapters.</a:t>
             </a:r>
           </a:p>
@@ -5874,6 +5970,7 @@
               </a:defRPr>
             </a:pPr>
             <a:r>
+              <a:rPr sz="1050"/>
               <a:t>• Generates Bloom's taxonomy practice quizzes &amp; 3D flashcards.</a:t>
             </a:r>
           </a:p>
@@ -5889,6 +5986,7 @@
               </a:defRPr>
             </a:pPr>
             <a:r>
+              <a:rPr sz="1050"/>
               <a:t>• 3 depth modes: Quick TL;DR, Detailed, and Executive Deep Dive.</a:t>
             </a:r>
           </a:p>
@@ -5936,6 +6034,7 @@
           <a:lstStyle/>
           <a:p>
             <a:pPr algn="ctr"/>
+            <a:endParaRPr sz="2400"/>
           </a:p>
         </p:txBody>
       </p:sp>
@@ -5975,7 +6074,7 @@
           </a:fontRef>
         </p:style>
         <p:txBody>
-          <a:bodyPr rtlCol="0" anchor="ctr" wrap="square"/>
+          <a:bodyPr wrap="square" rtlCol="0" anchor="ctr"/>
           <a:lstStyle/>
           <a:p>
             <a:pPr algn="ctr">
@@ -5986,6 +6085,7 @@
               </a:defRPr>
             </a:pPr>
             <a:r>
+              <a:rPr sz="1000"/>
               <a:t>CURRICULUM AUTHORING</a:t>
             </a:r>
           </a:p>
@@ -6000,7 +6100,7 @@
         <p:spPr>
           <a:xfrm>
             <a:off x="8238744" y="4462272"/>
-            <a:ext cx="3063240" cy="1783080"/>
+            <a:ext cx="3063240" cy="1759456"/>
           </a:xfrm>
           <a:prstGeom prst="rect">
             <a:avLst/>
@@ -6024,6 +6124,7 @@
               </a:defRPr>
             </a:pPr>
             <a:r>
+              <a:rPr sz="1600"/>
               <a:t>5-Tab Educator Studio</a:t>
             </a:r>
           </a:p>
@@ -6039,6 +6140,7 @@
               </a:defRPr>
             </a:pPr>
             <a:r>
+              <a:rPr sz="1050"/>
               <a:t>• Tab 1: Inline transcript editor with speaker diarization tags.</a:t>
             </a:r>
           </a:p>
@@ -6054,6 +6156,7 @@
               </a:defRPr>
             </a:pPr>
             <a:r>
+              <a:rPr sz="1050"/>
               <a:t>• Tab 2: Curriculum chapters builder with custom time markers.</a:t>
             </a:r>
           </a:p>
@@ -6069,6 +6172,7 @@
               </a:defRPr>
             </a:pPr>
             <a:r>
+              <a:rPr sz="1050"/>
               <a:t>• Tab 3: Assessment authoring with answer keys and explanations.</a:t>
             </a:r>
           </a:p>
@@ -6084,6 +6188,7 @@
               </a:defRPr>
             </a:pPr>
             <a:r>
+              <a:rPr sz="1050"/>
               <a:t>• Tabs 4 &amp; 5: Active recall flashcard decks &amp; live student preview.</a:t>
             </a:r>
           </a:p>
@@ -6098,7 +6203,7 @@
 </file>
 
 <file path=ppt/slides/slide4.xml><?xml version="1.0" encoding="utf-8"?>
-<p:sld xmlns:a="http://schemas.openxmlformats.org/drawingml/2006/main" xmlns:p="http://schemas.openxmlformats.org/presentationml/2006/main" xmlns:r="http://schemas.openxmlformats.org/officeDocument/2006/relationships">
+<p:sld xmlns:a="http://schemas.openxmlformats.org/drawingml/2006/main" xmlns:r="http://schemas.openxmlformats.org/officeDocument/2006/relationships" xmlns:p="http://schemas.openxmlformats.org/presentationml/2006/main">
   <p:cSld>
     <p:spTree>
       <p:nvGrpSpPr>
@@ -6106,7 +6211,14 @@
         <p:cNvGrpSpPr/>
         <p:nvPr/>
       </p:nvGrpSpPr>
-      <p:grpSpPr/>
+      <p:grpSpPr>
+        <a:xfrm>
+          <a:off x="0" y="0"/>
+          <a:ext cx="0" cy="0"/>
+          <a:chOff x="0" y="0"/>
+          <a:chExt cx="0" cy="0"/>
+        </a:xfrm>
+      </p:grpSpPr>
       <p:sp>
         <p:nvSpPr>
           <p:cNvPr id="2" name="Rectangle 1"/>
@@ -6147,6 +6259,7 @@
           <a:lstStyle/>
           <a:p>
             <a:pPr algn="ctr"/>
+            <a:endParaRPr/>
           </a:p>
         </p:txBody>
       </p:sp>
@@ -6260,6 +6373,7 @@
           <a:lstStyle/>
           <a:p>
             <a:pPr algn="ctr"/>
+            <a:endParaRPr/>
           </a:p>
         </p:txBody>
       </p:sp>
@@ -6305,6 +6419,7 @@
           <a:lstStyle/>
           <a:p>
             <a:pPr algn="ctr"/>
+            <a:endParaRPr/>
           </a:p>
         </p:txBody>
       </p:sp>
@@ -6395,6 +6510,7 @@
           <a:lstStyle/>
           <a:p>
             <a:pPr algn="ctr"/>
+            <a:endParaRPr/>
           </a:p>
         </p:txBody>
       </p:sp>
@@ -6440,6 +6556,7 @@
           <a:lstStyle/>
           <a:p>
             <a:pPr algn="ctr"/>
+            <a:endParaRPr/>
           </a:p>
         </p:txBody>
       </p:sp>
@@ -6530,6 +6647,7 @@
           <a:lstStyle/>
           <a:p>
             <a:pPr algn="ctr"/>
+            <a:endParaRPr/>
           </a:p>
         </p:txBody>
       </p:sp>
@@ -6575,6 +6693,7 @@
           <a:lstStyle/>
           <a:p>
             <a:pPr algn="ctr"/>
+            <a:endParaRPr/>
           </a:p>
         </p:txBody>
       </p:sp>
@@ -6667,6 +6786,7 @@
           <a:lstStyle/>
           <a:p>
             <a:pPr algn="ctr"/>
+            <a:endParaRPr/>
           </a:p>
         </p:txBody>
       </p:sp>
@@ -6763,6 +6883,7 @@
           <a:lstStyle/>
           <a:p>
             <a:pPr algn="ctr"/>
+            <a:endParaRPr/>
           </a:p>
         </p:txBody>
       </p:sp>
@@ -6826,7 +6947,7 @@
 </file>
 
 <file path=ppt/slides/slide5.xml><?xml version="1.0" encoding="utf-8"?>
-<p:sld xmlns:a="http://schemas.openxmlformats.org/drawingml/2006/main" xmlns:p="http://schemas.openxmlformats.org/presentationml/2006/main" xmlns:r="http://schemas.openxmlformats.org/officeDocument/2006/relationships">
+<p:sld xmlns:a="http://schemas.openxmlformats.org/drawingml/2006/main" xmlns:r="http://schemas.openxmlformats.org/officeDocument/2006/relationships" xmlns:p="http://schemas.openxmlformats.org/presentationml/2006/main">
   <p:cSld>
     <p:spTree>
       <p:nvGrpSpPr>
@@ -6834,7 +6955,14 @@
         <p:cNvGrpSpPr/>
         <p:nvPr/>
       </p:nvGrpSpPr>
-      <p:grpSpPr/>
+      <p:grpSpPr>
+        <a:xfrm>
+          <a:off x="0" y="0"/>
+          <a:ext cx="0" cy="0"/>
+          <a:chOff x="0" y="0"/>
+          <a:chExt cx="0" cy="0"/>
+        </a:xfrm>
+      </p:grpSpPr>
       <p:sp>
         <p:nvSpPr>
           <p:cNvPr id="2" name="Rectangle 1"/>
@@ -6875,6 +7003,7 @@
           <a:lstStyle/>
           <a:p>
             <a:pPr algn="ctr"/>
+            <a:endParaRPr sz="2800"/>
           </a:p>
         </p:txBody>
       </p:sp>
@@ -6887,7 +7016,7 @@
         <p:spPr>
           <a:xfrm>
             <a:off x="731520" y="365760"/>
-            <a:ext cx="10515600" cy="320040"/>
+            <a:ext cx="10515600" cy="276999"/>
           </a:xfrm>
           <a:prstGeom prst="rect">
             <a:avLst/>
@@ -6908,6 +7037,7 @@
               </a:defRPr>
             </a:pPr>
             <a:r>
+              <a:rPr sz="1200"/>
               <a:t>INFOSYS SPRINGBOARD • AI &amp; FULL-STACK CLOUD INTERNSHIP</a:t>
             </a:r>
           </a:p>
@@ -6922,7 +7052,7 @@
         <p:spPr>
           <a:xfrm>
             <a:off x="731520" y="640080"/>
-            <a:ext cx="10515600" cy="640080"/>
+            <a:ext cx="10515600" cy="1077218"/>
           </a:xfrm>
           <a:prstGeom prst="rect">
             <a:avLst/>
@@ -6943,6 +7073,7 @@
               </a:defRPr>
             </a:pPr>
             <a:r>
+              <a:rPr sz="3200"/>
               <a:t>4. End-to-End Processing Workflow (Complete Data Lifecycle)</a:t>
             </a:r>
           </a:p>
@@ -6988,6 +7119,7 @@
           <a:lstStyle/>
           <a:p>
             <a:pPr algn="ctr"/>
+            <a:endParaRPr sz="2800"/>
           </a:p>
         </p:txBody>
       </p:sp>
@@ -7033,6 +7165,7 @@
           <a:lstStyle/>
           <a:p>
             <a:pPr algn="ctr"/>
+            <a:endParaRPr sz="2800"/>
           </a:p>
         </p:txBody>
       </p:sp>
@@ -7072,7 +7205,7 @@
           </a:fontRef>
         </p:style>
         <p:txBody>
-          <a:bodyPr rtlCol="0" anchor="ctr" wrap="square"/>
+          <a:bodyPr wrap="square" rtlCol="0" anchor="ctr"/>
           <a:lstStyle/>
           <a:p>
             <a:pPr algn="ctr">
@@ -7083,6 +7216,7 @@
               </a:defRPr>
             </a:pPr>
             <a:r>
+              <a:rPr sz="1100"/>
               <a:t>Phase 1</a:t>
             </a:r>
           </a:p>
@@ -7097,7 +7231,7 @@
         <p:spPr>
           <a:xfrm>
             <a:off x="822960" y="1965960"/>
-            <a:ext cx="1691639" cy="4160520"/>
+            <a:ext cx="1645919" cy="2190343"/>
           </a:xfrm>
           <a:prstGeom prst="rect">
             <a:avLst/>
@@ -7121,6 +7255,7 @@
               </a:defRPr>
             </a:pPr>
             <a:r>
+              <a:rPr sz="1200" dirty="0"/>
               <a:t>Ingestion Sources</a:t>
             </a:r>
           </a:p>
@@ -7136,6 +7271,7 @@
               </a:defRPr>
             </a:pPr>
             <a:r>
+              <a:rPr sz="1200" dirty="0"/>
               <a:t>• Local Video Upload (MP4/MOV/MKV)</a:t>
             </a:r>
           </a:p>
@@ -7151,7 +7287,16 @@
               </a:defRPr>
             </a:pPr>
             <a:r>
-              <a:t>• yt-dlp YouTube Ingestion</a:t>
+              <a:rPr sz="1200" dirty="0"/>
+              <a:t>• </a:t>
+            </a:r>
+            <a:r>
+              <a:rPr sz="1200" dirty="0" err="1"/>
+              <a:t>yt-dlp</a:t>
+            </a:r>
+            <a:r>
+              <a:rPr sz="1200" dirty="0"/>
+              <a:t> YouTube Ingestion</a:t>
             </a:r>
           </a:p>
           <a:p>
@@ -7166,6 +7311,7 @@
               </a:defRPr>
             </a:pPr>
             <a:r>
+              <a:rPr sz="1200" dirty="0"/>
               <a:t>• Google Drive Direct Sync</a:t>
             </a:r>
           </a:p>
@@ -7181,6 +7327,7 @@
               </a:defRPr>
             </a:pPr>
             <a:r>
+              <a:rPr sz="1200" dirty="0"/>
               <a:t>• MIME check &amp; SHA-256 hash</a:t>
             </a:r>
           </a:p>
@@ -7226,6 +7373,7 @@
           <a:lstStyle/>
           <a:p>
             <a:pPr algn="ctr"/>
+            <a:endParaRPr sz="2800"/>
           </a:p>
         </p:txBody>
       </p:sp>
@@ -7271,6 +7419,7 @@
           <a:lstStyle/>
           <a:p>
             <a:pPr algn="ctr"/>
+            <a:endParaRPr sz="2800"/>
           </a:p>
         </p:txBody>
       </p:sp>
@@ -7310,7 +7459,7 @@
           </a:fontRef>
         </p:style>
         <p:txBody>
-          <a:bodyPr rtlCol="0" anchor="ctr" wrap="square"/>
+          <a:bodyPr wrap="square" rtlCol="0" anchor="ctr"/>
           <a:lstStyle/>
           <a:p>
             <a:pPr algn="ctr">
@@ -7321,6 +7470,7 @@
               </a:defRPr>
             </a:pPr>
             <a:r>
+              <a:rPr sz="1100"/>
               <a:t>Phase 2</a:t>
             </a:r>
           </a:p>
@@ -7335,7 +7485,7 @@
         <p:spPr>
           <a:xfrm>
             <a:off x="3035808" y="1965960"/>
-            <a:ext cx="1691639" cy="4160520"/>
+            <a:ext cx="1691639" cy="1728678"/>
           </a:xfrm>
           <a:prstGeom prst="rect">
             <a:avLst/>
@@ -7359,6 +7509,7 @@
               </a:defRPr>
             </a:pPr>
             <a:r>
+              <a:rPr sz="1200"/>
               <a:t>Gateway &amp; Cloud</a:t>
             </a:r>
           </a:p>
@@ -7374,6 +7525,7 @@
               </a:defRPr>
             </a:pPr>
             <a:r>
+              <a:rPr sz="1100"/>
               <a:t>• FastAPI ASGI Gateway</a:t>
             </a:r>
           </a:p>
@@ -7389,6 +7541,7 @@
               </a:defRPr>
             </a:pPr>
             <a:r>
+              <a:rPr sz="1100"/>
               <a:t>• Background Drive Auto-Backup</a:t>
             </a:r>
           </a:p>
@@ -7404,6 +7557,7 @@
               </a:defRPr>
             </a:pPr>
             <a:r>
+              <a:rPr sz="1100"/>
               <a:t>• Universal Buffer Fallback</a:t>
             </a:r>
           </a:p>
@@ -7419,6 +7573,7 @@
               </a:defRPr>
             </a:pPr>
             <a:r>
+              <a:rPr sz="1100"/>
               <a:t>• WebSocket Connection (/ws)</a:t>
             </a:r>
           </a:p>
@@ -7464,6 +7619,7 @@
           <a:lstStyle/>
           <a:p>
             <a:pPr algn="ctr"/>
+            <a:endParaRPr sz="2800"/>
           </a:p>
         </p:txBody>
       </p:sp>
@@ -7509,6 +7665,7 @@
           <a:lstStyle/>
           <a:p>
             <a:pPr algn="ctr"/>
+            <a:endParaRPr sz="2800"/>
           </a:p>
         </p:txBody>
       </p:sp>
@@ -7548,7 +7705,7 @@
           </a:fontRef>
         </p:style>
         <p:txBody>
-          <a:bodyPr rtlCol="0" anchor="ctr" wrap="square"/>
+          <a:bodyPr wrap="square" rtlCol="0" anchor="ctr"/>
           <a:lstStyle/>
           <a:p>
             <a:pPr algn="ctr">
@@ -7559,6 +7716,7 @@
               </a:defRPr>
             </a:pPr>
             <a:r>
+              <a:rPr sz="1100"/>
               <a:t>Phase 3</a:t>
             </a:r>
           </a:p>
@@ -7573,7 +7731,7 @@
         <p:spPr>
           <a:xfrm>
             <a:off x="5248655" y="1965960"/>
-            <a:ext cx="1691639" cy="4160520"/>
+            <a:ext cx="1691639" cy="1897955"/>
           </a:xfrm>
           <a:prstGeom prst="rect">
             <a:avLst/>
@@ -7597,6 +7755,7 @@
               </a:defRPr>
             </a:pPr>
             <a:r>
+              <a:rPr sz="1200"/>
               <a:t>Multimodal AI</a:t>
             </a:r>
           </a:p>
@@ -7612,6 +7771,7 @@
               </a:defRPr>
             </a:pPr>
             <a:r>
+              <a:rPr sz="1100"/>
               <a:t>• FFmpeg 16kHz Mono WAV Demux</a:t>
             </a:r>
           </a:p>
@@ -7627,6 +7787,7 @@
               </a:defRPr>
             </a:pPr>
             <a:r>
+              <a:rPr sz="1100"/>
               <a:t>• Whisper ASR (4.18% WER)</a:t>
             </a:r>
           </a:p>
@@ -7642,6 +7803,7 @@
               </a:defRPr>
             </a:pPr>
             <a:r>
+              <a:rPr sz="1100"/>
               <a:t>• LexRank + LLM Chapters</a:t>
             </a:r>
           </a:p>
@@ -7657,6 +7819,7 @@
               </a:defRPr>
             </a:pPr>
             <a:r>
+              <a:rPr sz="1100"/>
               <a:t>• OpenCV 1 fps Scene Cuts</a:t>
             </a:r>
           </a:p>
@@ -7702,6 +7865,7 @@
           <a:lstStyle/>
           <a:p>
             <a:pPr algn="ctr"/>
+            <a:endParaRPr sz="2800"/>
           </a:p>
         </p:txBody>
       </p:sp>
@@ -7747,6 +7911,7 @@
           <a:lstStyle/>
           <a:p>
             <a:pPr algn="ctr"/>
+            <a:endParaRPr sz="2800"/>
           </a:p>
         </p:txBody>
       </p:sp>
@@ -7786,7 +7951,7 @@
           </a:fontRef>
         </p:style>
         <p:txBody>
-          <a:bodyPr rtlCol="0" anchor="ctr" wrap="square"/>
+          <a:bodyPr wrap="square" rtlCol="0" anchor="ctr"/>
           <a:lstStyle/>
           <a:p>
             <a:pPr algn="ctr">
@@ -7797,6 +7962,7 @@
               </a:defRPr>
             </a:pPr>
             <a:r>
+              <a:rPr sz="1100"/>
               <a:t>Phase 4</a:t>
             </a:r>
           </a:p>
@@ -7811,7 +7977,7 @@
         <p:spPr>
           <a:xfrm>
             <a:off x="7461504" y="1965960"/>
-            <a:ext cx="1691639" cy="4160520"/>
+            <a:ext cx="1691639" cy="1897955"/>
           </a:xfrm>
           <a:prstGeom prst="rect">
             <a:avLst/>
@@ -7835,6 +8001,7 @@
               </a:defRPr>
             </a:pPr>
             <a:r>
+              <a:rPr sz="1200"/>
               <a:t>Persistence</a:t>
             </a:r>
           </a:p>
@@ -7850,6 +8017,7 @@
               </a:defRPr>
             </a:pPr>
             <a:r>
+              <a:rPr sz="1100"/>
               <a:t>• Relational SQL Users DB</a:t>
             </a:r>
           </a:p>
@@ -7865,6 +8033,7 @@
               </a:defRPr>
             </a:pPr>
             <a:r>
+              <a:rPr sz="1100"/>
               <a:t>• MongoDB Atlas Documents</a:t>
             </a:r>
           </a:p>
@@ -7880,6 +8049,7 @@
               </a:defRPr>
             </a:pPr>
             <a:r>
+              <a:rPr sz="1100"/>
               <a:t>• HTTP 206 Video Range Proxy</a:t>
             </a:r>
           </a:p>
@@ -7895,6 +8065,7 @@
               </a:defRPr>
             </a:pPr>
             <a:r>
+              <a:rPr sz="1100"/>
               <a:t>• Multi-Format Exporter Studio</a:t>
             </a:r>
           </a:p>
@@ -7940,6 +8111,7 @@
           <a:lstStyle/>
           <a:p>
             <a:pPr algn="ctr"/>
+            <a:endParaRPr sz="2800"/>
           </a:p>
         </p:txBody>
       </p:sp>
@@ -7985,6 +8157,7 @@
           <a:lstStyle/>
           <a:p>
             <a:pPr algn="ctr"/>
+            <a:endParaRPr sz="2800"/>
           </a:p>
         </p:txBody>
       </p:sp>
@@ -8024,7 +8197,7 @@
           </a:fontRef>
         </p:style>
         <p:txBody>
-          <a:bodyPr rtlCol="0" anchor="ctr" wrap="square"/>
+          <a:bodyPr wrap="square" rtlCol="0" anchor="ctr"/>
           <a:lstStyle/>
           <a:p>
             <a:pPr algn="ctr">
@@ -8035,6 +8208,7 @@
               </a:defRPr>
             </a:pPr>
             <a:r>
+              <a:rPr sz="1100"/>
               <a:t>Phase 5</a:t>
             </a:r>
           </a:p>
@@ -8049,7 +8223,7 @@
         <p:spPr>
           <a:xfrm>
             <a:off x="9674352" y="1965960"/>
-            <a:ext cx="1691639" cy="4160520"/>
+            <a:ext cx="1691639" cy="1728678"/>
           </a:xfrm>
           <a:prstGeom prst="rect">
             <a:avLst/>
@@ -8073,6 +8247,7 @@
               </a:defRPr>
             </a:pPr>
             <a:r>
+              <a:rPr sz="1200"/>
               <a:t>Role Workspaces</a:t>
             </a:r>
           </a:p>
@@ -8088,6 +8263,7 @@
               </a:defRPr>
             </a:pPr>
             <a:r>
+              <a:rPr sz="1100"/>
               <a:t>• Content Creator Studio</a:t>
             </a:r>
           </a:p>
@@ -8103,6 +8279,7 @@
               </a:defRPr>
             </a:pPr>
             <a:r>
+              <a:rPr sz="1100"/>
               <a:t>• Learner Interactive Study Room</a:t>
             </a:r>
           </a:p>
@@ -8118,6 +8295,7 @@
               </a:defRPr>
             </a:pPr>
             <a:r>
+              <a:rPr sz="1100"/>
               <a:t>• 5-Tab Educator Studio</a:t>
             </a:r>
           </a:p>
@@ -8133,6 +8311,7 @@
               </a:defRPr>
             </a:pPr>
             <a:r>
+              <a:rPr sz="1100"/>
               <a:t>• Administrator Governance Hub</a:t>
             </a:r>
           </a:p>
@@ -8147,7 +8326,7 @@
 </file>
 
 <file path=ppt/slides/slide6.xml><?xml version="1.0" encoding="utf-8"?>
-<p:sld xmlns:a="http://schemas.openxmlformats.org/drawingml/2006/main" xmlns:p="http://schemas.openxmlformats.org/presentationml/2006/main" xmlns:r="http://schemas.openxmlformats.org/officeDocument/2006/relationships">
+<p:sld xmlns:a="http://schemas.openxmlformats.org/drawingml/2006/main" xmlns:r="http://schemas.openxmlformats.org/officeDocument/2006/relationships" xmlns:p="http://schemas.openxmlformats.org/presentationml/2006/main">
   <p:cSld>
     <p:spTree>
       <p:nvGrpSpPr>
@@ -8155,7 +8334,14 @@
         <p:cNvGrpSpPr/>
         <p:nvPr/>
       </p:nvGrpSpPr>
-      <p:grpSpPr/>
+      <p:grpSpPr>
+        <a:xfrm>
+          <a:off x="0" y="0"/>
+          <a:ext cx="0" cy="0"/>
+          <a:chOff x="0" y="0"/>
+          <a:chExt cx="0" cy="0"/>
+        </a:xfrm>
+      </p:grpSpPr>
       <p:sp>
         <p:nvSpPr>
           <p:cNvPr id="2" name="Rectangle 1"/>
@@ -8196,6 +8382,7 @@
           <a:lstStyle/>
           <a:p>
             <a:pPr algn="ctr"/>
+            <a:endParaRPr sz="2400"/>
           </a:p>
         </p:txBody>
       </p:sp>
@@ -8208,7 +8395,7 @@
         <p:spPr>
           <a:xfrm>
             <a:off x="731520" y="365760"/>
-            <a:ext cx="10515600" cy="320040"/>
+            <a:ext cx="10515600" cy="261610"/>
           </a:xfrm>
           <a:prstGeom prst="rect">
             <a:avLst/>
@@ -8229,6 +8416,7 @@
               </a:defRPr>
             </a:pPr>
             <a:r>
+              <a:rPr sz="1100"/>
               <a:t>INFOSYS SPRINGBOARD • AI &amp; FULL-STACK CLOUD INTERNSHIP</a:t>
             </a:r>
           </a:p>
@@ -8243,7 +8431,7 @@
         <p:spPr>
           <a:xfrm>
             <a:off x="731520" y="640080"/>
-            <a:ext cx="10515600" cy="640080"/>
+            <a:ext cx="10515600" cy="523220"/>
           </a:xfrm>
           <a:prstGeom prst="rect">
             <a:avLst/>
@@ -8264,6 +8452,7 @@
               </a:defRPr>
             </a:pPr>
             <a:r>
+              <a:rPr sz="2800"/>
               <a:t>5. Detailed 7-Stage Video Processing Pipeline (Real-Time Telemetry)</a:t>
             </a:r>
           </a:p>
@@ -8309,6 +8498,7 @@
           <a:lstStyle/>
           <a:p>
             <a:pPr algn="ctr"/>
+            <a:endParaRPr sz="2400"/>
           </a:p>
         </p:txBody>
       </p:sp>
@@ -8354,6 +8544,7 @@
           <a:lstStyle/>
           <a:p>
             <a:pPr algn="ctr"/>
+            <a:endParaRPr sz="2400"/>
           </a:p>
         </p:txBody>
       </p:sp>
@@ -8393,7 +8584,7 @@
           </a:fontRef>
         </p:style>
         <p:txBody>
-          <a:bodyPr rtlCol="0" anchor="ctr" wrap="square"/>
+          <a:bodyPr wrap="square" rtlCol="0" anchor="ctr"/>
           <a:lstStyle/>
           <a:p>
             <a:pPr algn="ctr">
@@ -8404,6 +8595,7 @@
               </a:defRPr>
             </a:pPr>
             <a:r>
+              <a:rPr sz="1000"/>
               <a:t>Stage 1</a:t>
             </a:r>
           </a:p>
@@ -8445,7 +8637,7 @@
           </a:fontRef>
         </p:style>
         <p:txBody>
-          <a:bodyPr rtlCol="0" anchor="ctr" wrap="square"/>
+          <a:bodyPr wrap="square" rtlCol="0" anchor="ctr"/>
           <a:lstStyle/>
           <a:p>
             <a:pPr algn="ctr">
@@ -8456,6 +8648,7 @@
               </a:defRPr>
             </a:pPr>
             <a:r>
+              <a:rPr sz="1000"/>
               <a:t>15%</a:t>
             </a:r>
           </a:p>
@@ -8470,7 +8663,7 @@
         <p:spPr>
           <a:xfrm>
             <a:off x="868680" y="1965960"/>
-            <a:ext cx="2148840" cy="1600200"/>
+            <a:ext cx="2148840" cy="692497"/>
           </a:xfrm>
           <a:prstGeom prst="rect">
             <a:avLst/>
@@ -8494,6 +8687,7 @@
               </a:defRPr>
             </a:pPr>
             <a:r>
+              <a:rPr sz="1200"/>
               <a:t>Ingestion &amp; Probe</a:t>
             </a:r>
           </a:p>
@@ -8506,6 +8700,7 @@
               </a:defRPr>
             </a:pPr>
             <a:r>
+              <a:rPr sz="1100"/>
               <a:t>MIME check, UUID assign, Google Drive auto-sync</a:t>
             </a:r>
           </a:p>
@@ -8551,6 +8746,7 @@
           <a:lstStyle/>
           <a:p>
             <a:pPr algn="ctr"/>
+            <a:endParaRPr sz="2400"/>
           </a:p>
         </p:txBody>
       </p:sp>
@@ -8596,6 +8792,7 @@
           <a:lstStyle/>
           <a:p>
             <a:pPr algn="ctr"/>
+            <a:endParaRPr sz="2400"/>
           </a:p>
         </p:txBody>
       </p:sp>
@@ -8635,7 +8832,7 @@
           </a:fontRef>
         </p:style>
         <p:txBody>
-          <a:bodyPr rtlCol="0" anchor="ctr" wrap="square"/>
+          <a:bodyPr wrap="square" rtlCol="0" anchor="ctr"/>
           <a:lstStyle/>
           <a:p>
             <a:pPr algn="ctr">
@@ -8646,6 +8843,7 @@
               </a:defRPr>
             </a:pPr>
             <a:r>
+              <a:rPr sz="1000"/>
               <a:t>Stage 2</a:t>
             </a:r>
           </a:p>
@@ -8687,7 +8885,7 @@
           </a:fontRef>
         </p:style>
         <p:txBody>
-          <a:bodyPr rtlCol="0" anchor="ctr" wrap="square"/>
+          <a:bodyPr wrap="square" rtlCol="0" anchor="ctr"/>
           <a:lstStyle/>
           <a:p>
             <a:pPr algn="ctr">
@@ -8698,6 +8896,7 @@
               </a:defRPr>
             </a:pPr>
             <a:r>
+              <a:rPr sz="1000"/>
               <a:t>35%</a:t>
             </a:r>
           </a:p>
@@ -8712,7 +8911,7 @@
         <p:spPr>
           <a:xfrm>
             <a:off x="3566160" y="1965960"/>
-            <a:ext cx="2148840" cy="1600200"/>
+            <a:ext cx="2148840" cy="692497"/>
           </a:xfrm>
           <a:prstGeom prst="rect">
             <a:avLst/>
@@ -8736,6 +8935,7 @@
               </a:defRPr>
             </a:pPr>
             <a:r>
+              <a:rPr sz="1200"/>
               <a:t>Media Demuxing</a:t>
             </a:r>
           </a:p>
@@ -8748,6 +8948,7 @@
               </a:defRPr>
             </a:pPr>
             <a:r>
+              <a:rPr sz="1100"/>
               <a:t>FFmpeg audio extraction to 16kHz mono WAV</a:t>
             </a:r>
           </a:p>
@@ -8793,6 +8994,7 @@
           <a:lstStyle/>
           <a:p>
             <a:pPr algn="ctr"/>
+            <a:endParaRPr sz="2400"/>
           </a:p>
         </p:txBody>
       </p:sp>
@@ -8838,6 +9040,7 @@
           <a:lstStyle/>
           <a:p>
             <a:pPr algn="ctr"/>
+            <a:endParaRPr sz="2400"/>
           </a:p>
         </p:txBody>
       </p:sp>
@@ -8877,7 +9080,7 @@
           </a:fontRef>
         </p:style>
         <p:txBody>
-          <a:bodyPr rtlCol="0" anchor="ctr" wrap="square"/>
+          <a:bodyPr wrap="square" rtlCol="0" anchor="ctr"/>
           <a:lstStyle/>
           <a:p>
             <a:pPr algn="ctr">
@@ -8888,6 +9091,7 @@
               </a:defRPr>
             </a:pPr>
             <a:r>
+              <a:rPr sz="1000"/>
               <a:t>Stage 3</a:t>
             </a:r>
           </a:p>
@@ -8929,7 +9133,7 @@
           </a:fontRef>
         </p:style>
         <p:txBody>
-          <a:bodyPr rtlCol="0" anchor="ctr" wrap="square"/>
+          <a:bodyPr wrap="square" rtlCol="0" anchor="ctr"/>
           <a:lstStyle/>
           <a:p>
             <a:pPr algn="ctr">
@@ -8940,6 +9144,7 @@
               </a:defRPr>
             </a:pPr>
             <a:r>
+              <a:rPr sz="1000"/>
               <a:t>65%</a:t>
             </a:r>
           </a:p>
@@ -8954,7 +9159,7 @@
         <p:spPr>
           <a:xfrm>
             <a:off x="6263640" y="1965960"/>
-            <a:ext cx="2148840" cy="1600200"/>
+            <a:ext cx="2148840" cy="692497"/>
           </a:xfrm>
           <a:prstGeom prst="rect">
             <a:avLst/>
@@ -8978,6 +9183,7 @@
               </a:defRPr>
             </a:pPr>
             <a:r>
+              <a:rPr sz="1200"/>
               <a:t>Whisper STT</a:t>
             </a:r>
           </a:p>
@@ -8990,6 +9196,7 @@
               </a:defRPr>
             </a:pPr>
             <a:r>
+              <a:rPr sz="1100"/>
               <a:t>80-channel Log-Mel spectrograms, word timestamps</a:t>
             </a:r>
           </a:p>
@@ -9035,6 +9242,7 @@
           <a:lstStyle/>
           <a:p>
             <a:pPr algn="ctr"/>
+            <a:endParaRPr sz="2400"/>
           </a:p>
         </p:txBody>
       </p:sp>
@@ -9080,6 +9288,7 @@
           <a:lstStyle/>
           <a:p>
             <a:pPr algn="ctr"/>
+            <a:endParaRPr sz="2400"/>
           </a:p>
         </p:txBody>
       </p:sp>
@@ -9119,7 +9328,7 @@
           </a:fontRef>
         </p:style>
         <p:txBody>
-          <a:bodyPr rtlCol="0" anchor="ctr" wrap="square"/>
+          <a:bodyPr wrap="square" rtlCol="0" anchor="ctr"/>
           <a:lstStyle/>
           <a:p>
             <a:pPr algn="ctr">
@@ -9130,6 +9339,7 @@
               </a:defRPr>
             </a:pPr>
             <a:r>
+              <a:rPr sz="1000"/>
               <a:t>Stage 4</a:t>
             </a:r>
           </a:p>
@@ -9171,7 +9381,7 @@
           </a:fontRef>
         </p:style>
         <p:txBody>
-          <a:bodyPr rtlCol="0" anchor="ctr" wrap="square"/>
+          <a:bodyPr wrap="square" rtlCol="0" anchor="ctr"/>
           <a:lstStyle/>
           <a:p>
             <a:pPr algn="ctr">
@@ -9182,6 +9392,7 @@
               </a:defRPr>
             </a:pPr>
             <a:r>
+              <a:rPr sz="1000"/>
               <a:t>75%</a:t>
             </a:r>
           </a:p>
@@ -9196,7 +9407,7 @@
         <p:spPr>
           <a:xfrm>
             <a:off x="8961120" y="1965960"/>
-            <a:ext cx="2148840" cy="1600200"/>
+            <a:ext cx="2148840" cy="692497"/>
           </a:xfrm>
           <a:prstGeom prst="rect">
             <a:avLst/>
@@ -9220,6 +9431,7 @@
               </a:defRPr>
             </a:pPr>
             <a:r>
+              <a:rPr sz="1200"/>
               <a:t>Dual Summarization</a:t>
             </a:r>
           </a:p>
@@ -9232,6 +9444,7 @@
               </a:defRPr>
             </a:pPr>
             <a:r>
+              <a:rPr sz="1100"/>
               <a:t>LexRank TF-IDF graph + Generative LLM chapters</a:t>
             </a:r>
           </a:p>
@@ -9277,6 +9490,7 @@
           <a:lstStyle/>
           <a:p>
             <a:pPr algn="ctr"/>
+            <a:endParaRPr sz="2400"/>
           </a:p>
         </p:txBody>
       </p:sp>
@@ -9322,6 +9536,7 @@
           <a:lstStyle/>
           <a:p>
             <a:pPr algn="ctr"/>
+            <a:endParaRPr sz="2400"/>
           </a:p>
         </p:txBody>
       </p:sp>
@@ -9361,7 +9576,7 @@
           </a:fontRef>
         </p:style>
         <p:txBody>
-          <a:bodyPr rtlCol="0" anchor="ctr" wrap="square"/>
+          <a:bodyPr wrap="square" rtlCol="0" anchor="ctr"/>
           <a:lstStyle/>
           <a:p>
             <a:pPr algn="ctr">
@@ -9372,6 +9587,7 @@
               </a:defRPr>
             </a:pPr>
             <a:r>
+              <a:rPr sz="1000"/>
               <a:t>Stage 5</a:t>
             </a:r>
           </a:p>
@@ -9413,7 +9629,7 @@
           </a:fontRef>
         </p:style>
         <p:txBody>
-          <a:bodyPr rtlCol="0" anchor="ctr" wrap="square"/>
+          <a:bodyPr wrap="square" rtlCol="0" anchor="ctr"/>
           <a:lstStyle/>
           <a:p>
             <a:pPr algn="ctr">
@@ -9424,6 +9640,7 @@
               </a:defRPr>
             </a:pPr>
             <a:r>
+              <a:rPr sz="1000"/>
               <a:t>85%</a:t>
             </a:r>
           </a:p>
@@ -9438,7 +9655,7 @@
         <p:spPr>
           <a:xfrm>
             <a:off x="868680" y="4526280"/>
-            <a:ext cx="3063240" cy="1600200"/>
+            <a:ext cx="3063240" cy="523220"/>
           </a:xfrm>
           <a:prstGeom prst="rect">
             <a:avLst/>
@@ -9462,6 +9679,7 @@
               </a:defRPr>
             </a:pPr>
             <a:r>
+              <a:rPr sz="1200"/>
               <a:t>OpenCV Vision Cuts</a:t>
             </a:r>
           </a:p>
@@ -9474,6 +9692,7 @@
               </a:defRPr>
             </a:pPr>
             <a:r>
+              <a:rPr sz="1100"/>
               <a:t>1 fps pixel deltas, HSV histograms, slide transitions</a:t>
             </a:r>
           </a:p>
@@ -9519,6 +9738,7 @@
           <a:lstStyle/>
           <a:p>
             <a:pPr algn="ctr"/>
+            <a:endParaRPr sz="2400"/>
           </a:p>
         </p:txBody>
       </p:sp>
@@ -9564,6 +9784,7 @@
           <a:lstStyle/>
           <a:p>
             <a:pPr algn="ctr"/>
+            <a:endParaRPr sz="2400"/>
           </a:p>
         </p:txBody>
       </p:sp>
@@ -9603,7 +9824,7 @@
           </a:fontRef>
         </p:style>
         <p:txBody>
-          <a:bodyPr rtlCol="0" anchor="ctr" wrap="square"/>
+          <a:bodyPr wrap="square" rtlCol="0" anchor="ctr"/>
           <a:lstStyle/>
           <a:p>
             <a:pPr algn="ctr">
@@ -9614,6 +9835,7 @@
               </a:defRPr>
             </a:pPr>
             <a:r>
+              <a:rPr sz="1000"/>
               <a:t>Stage 6</a:t>
             </a:r>
           </a:p>
@@ -9655,7 +9877,7 @@
           </a:fontRef>
         </p:style>
         <p:txBody>
-          <a:bodyPr rtlCol="0" anchor="ctr" wrap="square"/>
+          <a:bodyPr wrap="square" rtlCol="0" anchor="ctr"/>
           <a:lstStyle/>
           <a:p>
             <a:pPr algn="ctr">
@@ -9666,6 +9888,7 @@
               </a:defRPr>
             </a:pPr>
             <a:r>
+              <a:rPr sz="1000"/>
               <a:t>90%</a:t>
             </a:r>
           </a:p>
@@ -9680,7 +9903,7 @@
         <p:spPr>
           <a:xfrm>
             <a:off x="4480560" y="4526280"/>
-            <a:ext cx="3063240" cy="1600200"/>
+            <a:ext cx="3063240" cy="523220"/>
           </a:xfrm>
           <a:prstGeom prst="rect">
             <a:avLst/>
@@ -9704,6 +9927,7 @@
               </a:defRPr>
             </a:pPr>
             <a:r>
+              <a:rPr sz="1200"/>
               <a:t>Concept Mind Map</a:t>
             </a:r>
           </a:p>
@@ -9716,6 +9940,7 @@
               </a:defRPr>
             </a:pPr>
             <a:r>
+              <a:rPr sz="1100"/>
               <a:t>Hierarchical concept graph synthesis, entity links</a:t>
             </a:r>
           </a:p>
@@ -9761,6 +9986,7 @@
           <a:lstStyle/>
           <a:p>
             <a:pPr algn="ctr"/>
+            <a:endParaRPr sz="2400"/>
           </a:p>
         </p:txBody>
       </p:sp>
@@ -9806,6 +10032,7 @@
           <a:lstStyle/>
           <a:p>
             <a:pPr algn="ctr"/>
+            <a:endParaRPr sz="2400"/>
           </a:p>
         </p:txBody>
       </p:sp>
@@ -9845,7 +10072,7 @@
           </a:fontRef>
         </p:style>
         <p:txBody>
-          <a:bodyPr rtlCol="0" anchor="ctr" wrap="square"/>
+          <a:bodyPr wrap="square" rtlCol="0" anchor="ctr"/>
           <a:lstStyle/>
           <a:p>
             <a:pPr algn="ctr">
@@ -9856,6 +10083,7 @@
               </a:defRPr>
             </a:pPr>
             <a:r>
+              <a:rPr sz="1000"/>
               <a:t>Stage 7</a:t>
             </a:r>
           </a:p>
@@ -9897,7 +10125,7 @@
           </a:fontRef>
         </p:style>
         <p:txBody>
-          <a:bodyPr rtlCol="0" anchor="ctr" wrap="square"/>
+          <a:bodyPr wrap="square" rtlCol="0" anchor="ctr"/>
           <a:lstStyle/>
           <a:p>
             <a:pPr algn="ctr">
@@ -9908,6 +10136,7 @@
               </a:defRPr>
             </a:pPr>
             <a:r>
+              <a:rPr sz="1000"/>
               <a:t>100%</a:t>
             </a:r>
           </a:p>
@@ -9922,7 +10151,7 @@
         <p:spPr>
           <a:xfrm>
             <a:off x="8092440" y="4526280"/>
-            <a:ext cx="3063240" cy="1600200"/>
+            <a:ext cx="3063240" cy="523220"/>
           </a:xfrm>
           <a:prstGeom prst="rect">
             <a:avLst/>
@@ -9946,6 +10175,7 @@
               </a:defRPr>
             </a:pPr>
             <a:r>
+              <a:rPr sz="1200"/>
               <a:t>Persistence &amp; 206</a:t>
             </a:r>
           </a:p>
@@ -9958,6 +10188,7 @@
               </a:defRPr>
             </a:pPr>
             <a:r>
+              <a:rPr sz="1100"/>
               <a:t>MongoDB document join, HTTP 206 stream ready</a:t>
             </a:r>
           </a:p>
@@ -9972,7 +10203,7 @@
 </file>
 
 <file path=ppt/slides/slide7.xml><?xml version="1.0" encoding="utf-8"?>
-<p:sld xmlns:a="http://schemas.openxmlformats.org/drawingml/2006/main" xmlns:p="http://schemas.openxmlformats.org/presentationml/2006/main" xmlns:r="http://schemas.openxmlformats.org/officeDocument/2006/relationships">
+<p:sld xmlns:a="http://schemas.openxmlformats.org/drawingml/2006/main" xmlns:r="http://schemas.openxmlformats.org/officeDocument/2006/relationships" xmlns:p="http://schemas.openxmlformats.org/presentationml/2006/main">
   <p:cSld>
     <p:spTree>
       <p:nvGrpSpPr>
@@ -9980,7 +10211,14 @@
         <p:cNvGrpSpPr/>
         <p:nvPr/>
       </p:nvGrpSpPr>
-      <p:grpSpPr/>
+      <p:grpSpPr>
+        <a:xfrm>
+          <a:off x="0" y="0"/>
+          <a:ext cx="0" cy="0"/>
+          <a:chOff x="0" y="0"/>
+          <a:chExt cx="0" cy="0"/>
+        </a:xfrm>
+      </p:grpSpPr>
       <p:sp>
         <p:nvSpPr>
           <p:cNvPr id="2" name="Rectangle 1"/>
@@ -10021,6 +10259,7 @@
           <a:lstStyle/>
           <a:p>
             <a:pPr algn="ctr"/>
+            <a:endParaRPr sz="2400"/>
           </a:p>
         </p:txBody>
       </p:sp>
@@ -10033,7 +10272,7 @@
         <p:spPr>
           <a:xfrm>
             <a:off x="731520" y="365760"/>
-            <a:ext cx="10515600" cy="320040"/>
+            <a:ext cx="10515600" cy="261610"/>
           </a:xfrm>
           <a:prstGeom prst="rect">
             <a:avLst/>
@@ -10054,6 +10293,7 @@
               </a:defRPr>
             </a:pPr>
             <a:r>
+              <a:rPr sz="1100"/>
               <a:t>INFOSYS SPRINGBOARD • AI &amp; FULL-STACK CLOUD INTERNSHIP</a:t>
             </a:r>
           </a:p>
@@ -10068,7 +10308,7 @@
         <p:spPr>
           <a:xfrm>
             <a:off x="731520" y="640080"/>
-            <a:ext cx="10515600" cy="640080"/>
+            <a:ext cx="10515600" cy="523220"/>
           </a:xfrm>
           <a:prstGeom prst="rect">
             <a:avLst/>
@@ -10089,6 +10329,7 @@
               </a:defRPr>
             </a:pPr>
             <a:r>
+              <a:rPr sz="2800"/>
               <a:t>6. Milestone-Wise Technical Implementation Roadmap (Weeks 1–8)</a:t>
             </a:r>
           </a:p>
@@ -10134,6 +10375,7 @@
           <a:lstStyle/>
           <a:p>
             <a:pPr algn="ctr"/>
+            <a:endParaRPr sz="2400"/>
           </a:p>
         </p:txBody>
       </p:sp>
@@ -10179,6 +10421,7 @@
           <a:lstStyle/>
           <a:p>
             <a:pPr algn="ctr"/>
+            <a:endParaRPr sz="2400"/>
           </a:p>
         </p:txBody>
       </p:sp>
@@ -10218,7 +10461,7 @@
           </a:fontRef>
         </p:style>
         <p:txBody>
-          <a:bodyPr rtlCol="0" anchor="ctr" wrap="square"/>
+          <a:bodyPr wrap="square" rtlCol="0" anchor="ctr"/>
           <a:lstStyle/>
           <a:p>
             <a:pPr algn="ctr">
@@ -10229,6 +10472,7 @@
               </a:defRPr>
             </a:pPr>
             <a:r>
+              <a:rPr sz="1000"/>
               <a:t>Milestone 1</a:t>
             </a:r>
           </a:p>
@@ -10270,7 +10514,7 @@
           </a:fontRef>
         </p:style>
         <p:txBody>
-          <a:bodyPr rtlCol="0" anchor="ctr" wrap="square"/>
+          <a:bodyPr wrap="square" rtlCol="0" anchor="ctr"/>
           <a:lstStyle/>
           <a:p>
             <a:pPr algn="ctr">
@@ -10281,6 +10525,7 @@
               </a:defRPr>
             </a:pPr>
             <a:r>
+              <a:rPr sz="1000"/>
               <a:t>PASSED 100%</a:t>
             </a:r>
           </a:p>
@@ -10295,7 +10540,7 @@
         <p:spPr>
           <a:xfrm>
             <a:off x="841248" y="1920240"/>
-            <a:ext cx="2203704" cy="4206240"/>
+            <a:ext cx="2203704" cy="3123932"/>
           </a:xfrm>
           <a:prstGeom prst="rect">
             <a:avLst/>
@@ -10319,6 +10564,7 @@
               </a:defRPr>
             </a:pPr>
             <a:r>
+              <a:rPr sz="1400"/>
               <a:t>WEEKS 1 &amp; 2</a:t>
             </a:r>
           </a:p>
@@ -10334,6 +10580,7 @@
               </a:defRPr>
             </a:pPr>
             <a:r>
+              <a:rPr sz="1100"/>
               <a:t>Architecture, Auth &amp; Video Ingestion</a:t>
             </a:r>
           </a:p>
@@ -10349,6 +10596,7 @@
               </a:defRPr>
             </a:pPr>
             <a:r>
+              <a:rPr sz="1050"/>
               <a:t>• Decoupled React 19 &amp; FastAPI architecture.</a:t>
             </a:r>
           </a:p>
@@ -10364,6 +10612,7 @@
               </a:defRPr>
             </a:pPr>
             <a:r>
+              <a:rPr sz="1050"/>
               <a:t>• Polyglot persistence: SQLite/PostgreSQL + Atlas.</a:t>
             </a:r>
           </a:p>
@@ -10379,6 +10628,7 @@
               </a:defRPr>
             </a:pPr>
             <a:r>
+              <a:rPr sz="1050"/>
               <a:t>• Salted Bcrypt hashing (cost 12) &amp; JWT tokens.</a:t>
             </a:r>
           </a:p>
@@ -10394,6 +10644,7 @@
               </a:defRPr>
             </a:pPr>
             <a:r>
+              <a:rPr sz="1050"/>
               <a:t>• Chunked multipart upload handler (.mp4, .mov).</a:t>
             </a:r>
           </a:p>
@@ -10409,6 +10660,7 @@
               </a:defRPr>
             </a:pPr>
             <a:r>
+              <a:rPr sz="1050"/>
               <a:t>• yt-dlp YouTube video and audio extractor.</a:t>
             </a:r>
           </a:p>
@@ -10424,6 +10676,7 @@
               </a:defRPr>
             </a:pPr>
             <a:r>
+              <a:rPr sz="1050"/>
               <a:t>• FFmpeg 16kHz mono WAV audio demuxer.</a:t>
             </a:r>
           </a:p>
@@ -10469,6 +10722,7 @@
           <a:lstStyle/>
           <a:p>
             <a:pPr algn="ctr"/>
+            <a:endParaRPr sz="2400"/>
           </a:p>
         </p:txBody>
       </p:sp>
@@ -10514,6 +10768,7 @@
           <a:lstStyle/>
           <a:p>
             <a:pPr algn="ctr"/>
+            <a:endParaRPr sz="2400"/>
           </a:p>
         </p:txBody>
       </p:sp>
@@ -10553,7 +10808,7 @@
           </a:fontRef>
         </p:style>
         <p:txBody>
-          <a:bodyPr rtlCol="0" anchor="ctr" wrap="square"/>
+          <a:bodyPr wrap="square" rtlCol="0" anchor="ctr"/>
           <a:lstStyle/>
           <a:p>
             <a:pPr algn="ctr">
@@ -10564,6 +10819,7 @@
               </a:defRPr>
             </a:pPr>
             <a:r>
+              <a:rPr sz="1000"/>
               <a:t>Milestone 2</a:t>
             </a:r>
           </a:p>
@@ -10605,7 +10861,7 @@
           </a:fontRef>
         </p:style>
         <p:txBody>
-          <a:bodyPr rtlCol="0" anchor="ctr" wrap="square"/>
+          <a:bodyPr wrap="square" rtlCol="0" anchor="ctr"/>
           <a:lstStyle/>
           <a:p>
             <a:pPr algn="ctr">
@@ -10616,6 +10872,7 @@
               </a:defRPr>
             </a:pPr>
             <a:r>
+              <a:rPr sz="1000"/>
               <a:t>PASSED 100%</a:t>
             </a:r>
           </a:p>
@@ -10630,7 +10887,7 @@
         <p:spPr>
           <a:xfrm>
             <a:off x="3611880" y="1920240"/>
-            <a:ext cx="2203704" cy="4206240"/>
+            <a:ext cx="2203704" cy="3123932"/>
           </a:xfrm>
           <a:prstGeom prst="rect">
             <a:avLst/>
@@ -10654,6 +10911,7 @@
               </a:defRPr>
             </a:pPr>
             <a:r>
+              <a:rPr sz="1400"/>
               <a:t>WEEKS 3 &amp; 4</a:t>
             </a:r>
           </a:p>
@@ -10669,6 +10927,7 @@
               </a:defRPr>
             </a:pPr>
             <a:r>
+              <a:rPr sz="1100"/>
               <a:t>Speech-to-Text &amp; AI Summarization</a:t>
             </a:r>
           </a:p>
@@ -10684,6 +10943,7 @@
               </a:defRPr>
             </a:pPr>
             <a:r>
+              <a:rPr sz="1050"/>
               <a:t>• OpenAI Whisper ASR transformer model.</a:t>
             </a:r>
           </a:p>
@@ -10699,6 +10959,7 @@
               </a:defRPr>
             </a:pPr>
             <a:r>
+              <a:rPr sz="1050"/>
               <a:t>• Word-level timestamps &amp; segment indexation.</a:t>
             </a:r>
           </a:p>
@@ -10714,6 +10975,7 @@
               </a:defRPr>
             </a:pPr>
             <a:r>
+              <a:rPr sz="1050"/>
               <a:t>• LexRank graph centrality extractive TL;DR (&lt;1.5s).</a:t>
             </a:r>
           </a:p>
@@ -10729,6 +10991,7 @@
               </a:defRPr>
             </a:pPr>
             <a:r>
+              <a:rPr sz="1050"/>
               <a:t>• Abstractive LLM chapters and key takeaways.</a:t>
             </a:r>
           </a:p>
@@ -10744,6 +11007,7 @@
               </a:defRPr>
             </a:pPr>
             <a:r>
+              <a:rPr sz="1050"/>
               <a:t>• Interactive transcript viewer with click-to-seek.</a:t>
             </a:r>
           </a:p>
@@ -10759,6 +11023,7 @@
               </a:defRPr>
             </a:pPr>
             <a:r>
+              <a:rPr sz="1050"/>
               <a:t>• Verified 4.18% WER (95.82% speech accuracy).</a:t>
             </a:r>
           </a:p>
@@ -10804,6 +11069,7 @@
           <a:lstStyle/>
           <a:p>
             <a:pPr algn="ctr"/>
+            <a:endParaRPr sz="2400"/>
           </a:p>
         </p:txBody>
       </p:sp>
@@ -10849,6 +11115,7 @@
           <a:lstStyle/>
           <a:p>
             <a:pPr algn="ctr"/>
+            <a:endParaRPr sz="2400"/>
           </a:p>
         </p:txBody>
       </p:sp>
@@ -10888,7 +11155,7 @@
           </a:fontRef>
         </p:style>
         <p:txBody>
-          <a:bodyPr rtlCol="0" anchor="ctr" wrap="square"/>
+          <a:bodyPr wrap="square" rtlCol="0" anchor="ctr"/>
           <a:lstStyle/>
           <a:p>
             <a:pPr algn="ctr">
@@ -10899,6 +11166,7 @@
               </a:defRPr>
             </a:pPr>
             <a:r>
+              <a:rPr sz="1000"/>
               <a:t>Milestone 3</a:t>
             </a:r>
           </a:p>
@@ -10940,7 +11208,7 @@
           </a:fontRef>
         </p:style>
         <p:txBody>
-          <a:bodyPr rtlCol="0" anchor="ctr" wrap="square"/>
+          <a:bodyPr wrap="square" rtlCol="0" anchor="ctr"/>
           <a:lstStyle/>
           <a:p>
             <a:pPr algn="ctr">
@@ -10951,6 +11219,7 @@
               </a:defRPr>
             </a:pPr>
             <a:r>
+              <a:rPr sz="1000"/>
               <a:t>PASSED 100%</a:t>
             </a:r>
           </a:p>
@@ -10965,7 +11234,7 @@
         <p:spPr>
           <a:xfrm>
             <a:off x="6382512" y="1920240"/>
-            <a:ext cx="2203704" cy="4206240"/>
+            <a:ext cx="2203704" cy="2954655"/>
           </a:xfrm>
           <a:prstGeom prst="rect">
             <a:avLst/>
@@ -10989,6 +11258,7 @@
               </a:defRPr>
             </a:pPr>
             <a:r>
+              <a:rPr sz="1400"/>
               <a:t>WEEKS 5 &amp; 6</a:t>
             </a:r>
           </a:p>
@@ -11004,6 +11274,7 @@
               </a:defRPr>
             </a:pPr>
             <a:r>
+              <a:rPr sz="1100"/>
               <a:t>Key Moments &amp; Educator Studio</a:t>
             </a:r>
           </a:p>
@@ -11019,6 +11290,7 @@
               </a:defRPr>
             </a:pPr>
             <a:r>
+              <a:rPr sz="1050"/>
               <a:t>• OpenCV 1 fps frame deltas &amp; HSV histograms.</a:t>
             </a:r>
           </a:p>
@@ -11034,6 +11306,7 @@
               </a:defRPr>
             </a:pPr>
             <a:r>
+              <a:rPr sz="1050"/>
               <a:t>• 5-Tab Educator Studio (Transcripts to Preview).</a:t>
             </a:r>
           </a:p>
@@ -11049,6 +11322,7 @@
               </a:defRPr>
             </a:pPr>
             <a:r>
+              <a:rPr sz="1050"/>
               <a:t>• Learner Study Room with auto-graded quizzes.</a:t>
             </a:r>
           </a:p>
@@ -11064,6 +11338,7 @@
               </a:defRPr>
             </a:pPr>
             <a:r>
+              <a:rPr sz="1050"/>
               <a:t>• 3D active recall flip flashcards with mastery.</a:t>
             </a:r>
           </a:p>
@@ -11079,6 +11354,7 @@
               </a:defRPr>
             </a:pPr>
             <a:r>
+              <a:rPr sz="1050"/>
               <a:t>• Multi-format document exporter (PDF, DOCX, etc.).</a:t>
             </a:r>
           </a:p>
@@ -11094,6 +11370,7 @@
               </a:defRPr>
             </a:pPr>
             <a:r>
+              <a:rPr sz="1050"/>
               <a:t>• Bidirectional WebSocket progress telemetry hub.</a:t>
             </a:r>
           </a:p>
@@ -11139,6 +11416,7 @@
           <a:lstStyle/>
           <a:p>
             <a:pPr algn="ctr"/>
+            <a:endParaRPr sz="2400"/>
           </a:p>
         </p:txBody>
       </p:sp>
@@ -11184,6 +11462,7 @@
           <a:lstStyle/>
           <a:p>
             <a:pPr algn="ctr"/>
+            <a:endParaRPr sz="2400"/>
           </a:p>
         </p:txBody>
       </p:sp>
@@ -11223,7 +11502,7 @@
           </a:fontRef>
         </p:style>
         <p:txBody>
-          <a:bodyPr rtlCol="0" anchor="ctr" wrap="square"/>
+          <a:bodyPr wrap="square" rtlCol="0" anchor="ctr"/>
           <a:lstStyle/>
           <a:p>
             <a:pPr algn="ctr">
@@ -11234,6 +11513,7 @@
               </a:defRPr>
             </a:pPr>
             <a:r>
+              <a:rPr sz="1000"/>
               <a:t>Milestone 4</a:t>
             </a:r>
           </a:p>
@@ -11275,7 +11555,7 @@
           </a:fontRef>
         </p:style>
         <p:txBody>
-          <a:bodyPr rtlCol="0" anchor="ctr" wrap="square"/>
+          <a:bodyPr wrap="square" rtlCol="0" anchor="ctr"/>
           <a:lstStyle/>
           <a:p>
             <a:pPr algn="ctr">
@@ -11286,6 +11566,7 @@
               </a:defRPr>
             </a:pPr>
             <a:r>
+              <a:rPr sz="1000"/>
               <a:t>PASSED 100%</a:t>
             </a:r>
           </a:p>
@@ -11300,7 +11581,7 @@
         <p:spPr>
           <a:xfrm>
             <a:off x="9153144" y="1920240"/>
-            <a:ext cx="2203704" cy="4206240"/>
+            <a:ext cx="2203704" cy="3123932"/>
           </a:xfrm>
           <a:prstGeom prst="rect">
             <a:avLst/>
@@ -11324,6 +11605,7 @@
               </a:defRPr>
             </a:pPr>
             <a:r>
+              <a:rPr sz="1400"/>
               <a:t>WEEKS 7 &amp; 8</a:t>
             </a:r>
           </a:p>
@@ -11339,6 +11621,7 @@
               </a:defRPr>
             </a:pPr>
             <a:r>
+              <a:rPr sz="1100"/>
               <a:t>Zero-Loss Cloud &amp; Production Delivery</a:t>
             </a:r>
           </a:p>
@@ -11354,6 +11637,7 @@
               </a:defRPr>
             </a:pPr>
             <a:r>
+              <a:rPr sz="1050"/>
               <a:t>• Google Drive API v3 (15GB persistent cloud).</a:t>
             </a:r>
           </a:p>
@@ -11369,6 +11653,7 @@
               </a:defRPr>
             </a:pPr>
             <a:r>
+              <a:rPr sz="1050"/>
               <a:t>• HTTP 206 Partial Content range video proxy.</a:t>
             </a:r>
           </a:p>
@@ -11384,6 +11669,7 @@
               </a:defRPr>
             </a:pPr>
             <a:r>
+              <a:rPr sz="1050"/>
               <a:t>• Interactive AI Concept Mind Map canvas.</a:t>
             </a:r>
           </a:p>
@@ -11399,6 +11685,7 @@
               </a:defRPr>
             </a:pPr>
             <a:r>
+              <a:rPr sz="1050"/>
               <a:t>• Human-crafted dark/light engineering UI.</a:t>
             </a:r>
           </a:p>
@@ -11414,6 +11701,7 @@
               </a:defRPr>
             </a:pPr>
             <a:r>
+              <a:rPr sz="1050"/>
               <a:t>• Multi-stage Dockerfiles &amp; docker-compose.yml.</a:t>
             </a:r>
           </a:p>
@@ -11429,6 +11717,7 @@
               </a:defRPr>
             </a:pPr>
             <a:r>
+              <a:rPr sz="1050"/>
               <a:t>• 100% automated test suite pass rate.</a:t>
             </a:r>
           </a:p>
@@ -11443,7 +11732,7 @@
 </file>
 
 <file path=ppt/slides/slide8.xml><?xml version="1.0" encoding="utf-8"?>
-<p:sld xmlns:a="http://schemas.openxmlformats.org/drawingml/2006/main" xmlns:p="http://schemas.openxmlformats.org/presentationml/2006/main" xmlns:r="http://schemas.openxmlformats.org/officeDocument/2006/relationships">
+<p:sld xmlns:a="http://schemas.openxmlformats.org/drawingml/2006/main" xmlns:r="http://schemas.openxmlformats.org/officeDocument/2006/relationships" xmlns:p="http://schemas.openxmlformats.org/presentationml/2006/main">
   <p:cSld>
     <p:spTree>
       <p:nvGrpSpPr>
@@ -11451,7 +11740,14 @@
         <p:cNvGrpSpPr/>
         <p:nvPr/>
       </p:nvGrpSpPr>
-      <p:grpSpPr/>
+      <p:grpSpPr>
+        <a:xfrm>
+          <a:off x="0" y="0"/>
+          <a:ext cx="0" cy="0"/>
+          <a:chOff x="0" y="0"/>
+          <a:chExt cx="0" cy="0"/>
+        </a:xfrm>
+      </p:grpSpPr>
       <p:sp>
         <p:nvSpPr>
           <p:cNvPr id="2" name="Rectangle 1"/>
@@ -11492,6 +11788,7 @@
           <a:lstStyle/>
           <a:p>
             <a:pPr algn="ctr"/>
+            <a:endParaRPr sz="4000"/>
           </a:p>
         </p:txBody>
       </p:sp>
@@ -11504,7 +11801,7 @@
         <p:spPr>
           <a:xfrm>
             <a:off x="731520" y="365760"/>
-            <a:ext cx="10515600" cy="320040"/>
+            <a:ext cx="10515600" cy="246221"/>
           </a:xfrm>
           <a:prstGeom prst="rect">
             <a:avLst/>
@@ -11539,7 +11836,7 @@
         <p:spPr>
           <a:xfrm>
             <a:off x="731520" y="640080"/>
-            <a:ext cx="10515600" cy="640080"/>
+            <a:ext cx="10515600" cy="523220"/>
           </a:xfrm>
           <a:prstGeom prst="rect">
             <a:avLst/>
@@ -11560,6 +11857,7 @@
               </a:defRPr>
             </a:pPr>
             <a:r>
+              <a:rPr sz="2800" dirty="0"/>
               <a:t>7. Multi-Persona Role-Based Access Control (RBAC) &amp; Educator Studio</a:t>
             </a:r>
           </a:p>
@@ -11605,6 +11903,7 @@
           <a:lstStyle/>
           <a:p>
             <a:pPr algn="ctr"/>
+            <a:endParaRPr sz="4000"/>
           </a:p>
         </p:txBody>
       </p:sp>
@@ -11650,6 +11949,7 @@
           <a:lstStyle/>
           <a:p>
             <a:pPr algn="ctr"/>
+            <a:endParaRPr sz="4000"/>
           </a:p>
         </p:txBody>
       </p:sp>
@@ -11662,7 +11962,7 @@
         <p:spPr>
           <a:xfrm>
             <a:off x="914400" y="1600200"/>
-            <a:ext cx="4846320" cy="2194560"/>
+            <a:ext cx="4846320" cy="723275"/>
           </a:xfrm>
           <a:prstGeom prst="rect">
             <a:avLst/>
@@ -11701,6 +12001,7 @@
               </a:defRPr>
             </a:pPr>
             <a:r>
+              <a:rPr sz="1100"/>
               <a:t>Uploads videos, ingests YouTube URLs, monitors AI pipeline, views analytics, and exports packages in PDF, DOCX, TXT, SRT, VTT.</a:t>
             </a:r>
           </a:p>
@@ -11748,6 +12049,7 @@
           <a:lstStyle/>
           <a:p>
             <a:pPr algn="ctr"/>
+            <a:endParaRPr sz="4000"/>
           </a:p>
         </p:txBody>
       </p:sp>
@@ -11760,7 +12062,7 @@
         <p:spPr>
           <a:xfrm>
             <a:off x="6400800" y="1600200"/>
-            <a:ext cx="4846320" cy="2194560"/>
+            <a:ext cx="4846320" cy="723275"/>
           </a:xfrm>
           <a:prstGeom prst="rect">
             <a:avLst/>
@@ -11799,6 +12101,7 @@
               </a:defRPr>
             </a:pPr>
             <a:r>
+              <a:rPr sz="1100"/>
               <a:t>Synchronized video player with auto-scrolling transcripts, click-to-seek, interactive auto-graded quizzes, and 3D flashcards.</a:t>
             </a:r>
           </a:p>
@@ -11846,6 +12149,7 @@
           <a:lstStyle/>
           <a:p>
             <a:pPr algn="ctr"/>
+            <a:endParaRPr sz="4000"/>
           </a:p>
         </p:txBody>
       </p:sp>
@@ -11858,7 +12162,7 @@
         <p:spPr>
           <a:xfrm>
             <a:off x="914400" y="3977640"/>
-            <a:ext cx="4846320" cy="2194560"/>
+            <a:ext cx="4846320" cy="1377300"/>
           </a:xfrm>
           <a:prstGeom prst="rect">
             <a:avLst/>
@@ -11897,6 +12201,7 @@
               </a:defRPr>
             </a:pPr>
             <a:r>
+              <a:rPr sz="1100"/>
               <a:t>Tab 1: Transcript Editor &amp; Diarization</a:t>
             </a:r>
           </a:p>
@@ -11912,6 +12217,7 @@
               </a:defRPr>
             </a:pPr>
             <a:r>
+              <a:rPr sz="1100"/>
               <a:t>Tab 2: Curriculum Chapters &amp; Time Bounds</a:t>
             </a:r>
           </a:p>
@@ -11927,6 +12233,7 @@
               </a:defRPr>
             </a:pPr>
             <a:r>
+              <a:rPr sz="1100"/>
               <a:t>Tab 3: Interactive Quiz Authoring</a:t>
             </a:r>
           </a:p>
@@ -11942,6 +12249,7 @@
               </a:defRPr>
             </a:pPr>
             <a:r>
+              <a:rPr sz="1100"/>
               <a:t>Tab 4: Flashcard Decks</a:t>
             </a:r>
           </a:p>
@@ -11957,6 +12265,7 @@
               </a:defRPr>
             </a:pPr>
             <a:r>
+              <a:rPr sz="1100"/>
               <a:t>Tab 5: Live Student Preview</a:t>
             </a:r>
           </a:p>
@@ -12004,6 +12313,7 @@
           <a:lstStyle/>
           <a:p>
             <a:pPr algn="ctr"/>
+            <a:endParaRPr sz="4000"/>
           </a:p>
         </p:txBody>
       </p:sp>
@@ -12016,7 +12326,7 @@
         <p:spPr>
           <a:xfrm>
             <a:off x="6400800" y="3977640"/>
-            <a:ext cx="4846320" cy="2194560"/>
+            <a:ext cx="4846320" cy="723275"/>
           </a:xfrm>
           <a:prstGeom prst="rect">
             <a:avLst/>
@@ -12055,6 +12365,7 @@
               </a:defRPr>
             </a:pPr>
             <a:r>
+              <a:rPr sz="1100"/>
               <a:t>Complete user governance, RBAC reassignment, real-time telemetry, 50+ event system audit warehouse, and 1-click cache purges.</a:t>
             </a:r>
           </a:p>
@@ -12069,7 +12380,7 @@
 </file>
 
 <file path=ppt/slides/slide9.xml><?xml version="1.0" encoding="utf-8"?>
-<p:sld xmlns:a="http://schemas.openxmlformats.org/drawingml/2006/main" xmlns:p="http://schemas.openxmlformats.org/presentationml/2006/main" xmlns:r="http://schemas.openxmlformats.org/officeDocument/2006/relationships">
+<p:sld xmlns:a="http://schemas.openxmlformats.org/drawingml/2006/main" xmlns:r="http://schemas.openxmlformats.org/officeDocument/2006/relationships" xmlns:p="http://schemas.openxmlformats.org/presentationml/2006/main">
   <p:cSld>
     <p:spTree>
       <p:nvGrpSpPr>
@@ -12077,7 +12388,14 @@
         <p:cNvGrpSpPr/>
         <p:nvPr/>
       </p:nvGrpSpPr>
-      <p:grpSpPr/>
+      <p:grpSpPr>
+        <a:xfrm>
+          <a:off x="0" y="0"/>
+          <a:ext cx="0" cy="0"/>
+          <a:chOff x="0" y="0"/>
+          <a:chExt cx="0" cy="0"/>
+        </a:xfrm>
+      </p:grpSpPr>
       <p:sp>
         <p:nvSpPr>
           <p:cNvPr id="2" name="Rectangle 1"/>
@@ -12118,6 +12436,7 @@
           <a:lstStyle/>
           <a:p>
             <a:pPr algn="ctr"/>
+            <a:endParaRPr/>
           </a:p>
         </p:txBody>
       </p:sp>
@@ -12231,6 +12550,7 @@
           <a:lstStyle/>
           <a:p>
             <a:pPr algn="ctr"/>
+            <a:endParaRPr/>
           </a:p>
         </p:txBody>
       </p:sp>
@@ -12276,6 +12596,7 @@
           <a:lstStyle/>
           <a:p>
             <a:pPr algn="ctr"/>
+            <a:endParaRPr/>
           </a:p>
         </p:txBody>
       </p:sp>
@@ -12386,6 +12707,7 @@
           <a:lstStyle/>
           <a:p>
             <a:pPr algn="ctr"/>
+            <a:endParaRPr/>
           </a:p>
         </p:txBody>
       </p:sp>
@@ -12496,6 +12818,7 @@
           <a:lstStyle/>
           <a:p>
             <a:pPr algn="ctr"/>
+            <a:endParaRPr/>
           </a:p>
         </p:txBody>
       </p:sp>
@@ -12606,6 +12929,7 @@
           <a:lstStyle/>
           <a:p>
             <a:pPr algn="ctr"/>
+            <a:endParaRPr/>
           </a:p>
         </p:txBody>
       </p:sp>
@@ -12716,6 +13040,7 @@
           <a:lstStyle/>
           <a:p>
             <a:pPr algn="ctr"/>
+            <a:endParaRPr/>
           </a:p>
         </p:txBody>
       </p:sp>
@@ -12826,6 +13151,7 @@
           <a:lstStyle/>
           <a:p>
             <a:pPr algn="ctr"/>
+            <a:endParaRPr/>
           </a:p>
         </p:txBody>
       </p:sp>

</xml_diff>